<commit_message>
Remove the ending slide from the 冠詞 deck for now (18 slides)
The deck now ends on the third next-time preview slide
(数えられない名詞). The ending slide is in git history if it comes back.

Co-Authored-By: Claude Opus 5.5 <noreply@anthropic.com>
Claude-Session: https://claude.ai/code/session_01AdzV2rtokspoPMcfpFKx4K
</commit_message>
<xml_diff>
--- a/matome/a-the/a-the-slides.pptx
+++ b/matome/a-the/a-the-slides.pptx
@@ -23,7 +23,6 @@
     <p:sldId id="271" r:id="rId17"/>
     <p:sldId id="272" r:id="rId18"/>
     <p:sldId id="273" r:id="rId19"/>
-    <p:sldId id="274" r:id="rId20"/>
   </p:sldIdLst>
   <p:sldSz cx="12192000" cy="6858000"/>
   <p:notesSz cx="6858000" cy="12192000"/>
@@ -8243,266 +8242,6 @@
 </p:sld>
 </file>
 
-<file path=ppt/slides/slide19.xml><?xml version="1.0" encoding="utf-8"?>
-<p:sld xmlns:a="http://schemas.openxmlformats.org/drawingml/2006/main" xmlns:r="http://schemas.openxmlformats.org/officeDocument/2006/relationships" xmlns:p="http://schemas.openxmlformats.org/presentationml/2006/main">
-  <p:cSld name="Slide 19">
-    <p:bg>
-      <p:bgPr>
-        <a:solidFill>
-          <a:srgbClr val="EAF2FB"/>
-        </a:solidFill>
-      </p:bgPr>
-    </p:bg>
-    <p:spTree>
-      <p:nvGrpSpPr>
-        <p:cNvPr id="1" name=""/>
-        <p:cNvGrpSpPr/>
-        <p:nvPr/>
-      </p:nvGrpSpPr>
-      <p:grpSpPr>
-        <a:xfrm>
-          <a:off x="0" y="0"/>
-          <a:ext cx="0" cy="0"/>
-          <a:chOff x="0" y="0"/>
-          <a:chExt cx="0" cy="0"/>
-        </a:xfrm>
-      </p:grpSpPr>
-      <p:sp>
-        <p:nvSpPr>
-          <p:cNvPr id="2" name=""/>
-          <p:cNvSpPr/>
-          <p:nvPr/>
-        </p:nvSpPr>
-        <p:spPr>
-          <a:xfrm>
-            <a:off x="419100" y="419100"/>
-            <a:ext cx="11353800" cy="6019800"/>
-          </a:xfrm>
-          <a:prstGeom prst="roundRect">
-            <a:avLst>
-              <a:gd name="adj" fmla="val 6962"/>
-            </a:avLst>
-          </a:prstGeom>
-          <a:solidFill>
-            <a:srgbClr val="FFDCCB"/>
-          </a:solidFill>
-          <a:ln/>
-          <a:effectLst>
-            <a:outerShdw sx="100000" sy="100000" kx="0" ky="0" algn="bl" rotWithShape="0" blurRad="152400" dist="50800" dir="5400000">
-              <a:srgbClr val="22304A">
-                <a:alpha val="10000"/>
-              </a:srgbClr>
-            </a:outerShdw>
-          </a:effectLst>
-        </p:spPr>
-      </p:sp>
-      <p:sp>
-        <p:nvSpPr>
-          <p:cNvPr id="3" name=""/>
-          <p:cNvSpPr txBox="1"/>
-          <p:nvPr/>
-        </p:nvSpPr>
-        <p:spPr>
-          <a:xfrm>
-            <a:off x="1181100" y="1457325"/>
-            <a:ext cx="1162050" cy="276225"/>
-          </a:xfrm>
-          <a:prstGeom prst="rect">
-            <a:avLst/>
-          </a:prstGeom>
-          <a:noFill/>
-          <a:ln/>
-        </p:spPr>
-        <p:txBody>
-          <a:bodyPr wrap="square" lIns="0" tIns="0" rIns="0" bIns="0" anchor="ctr"/>
-          <a:lstStyle/>
-          <a:p>
-            <a:pPr/>
-            <a:r>
-              <a:rPr sz="1650" b="1">
-                <a:solidFill>
-                  <a:srgbClr val="C8401A"/>
-                </a:solidFill>
-                <a:latin typeface="DM Sans"/>
-                <a:ea typeface="DM Sans"/>
-              </a:rPr>
-              <a:t>NEXT</a:t>
-            </a:r>
-          </a:p>
-        </p:txBody>
-      </p:sp>
-      <p:sp>
-        <p:nvSpPr>
-          <p:cNvPr id="4" name=""/>
-          <p:cNvSpPr txBox="1"/>
-          <p:nvPr/>
-        </p:nvSpPr>
-        <p:spPr>
-          <a:xfrm>
-            <a:off x="1181100" y="1714500"/>
-            <a:ext cx="3362325" cy="1266825"/>
-          </a:xfrm>
-          <a:prstGeom prst="rect">
-            <a:avLst/>
-          </a:prstGeom>
-          <a:noFill/>
-          <a:ln/>
-        </p:spPr>
-        <p:txBody>
-          <a:bodyPr wrap="square" lIns="0" tIns="0" rIns="0" bIns="0" anchor="ctr"/>
-          <a:lstStyle/>
-          <a:p>
-            <a:pPr/>
-            <a:r>
-              <a:rPr sz="6900" b="1">
-                <a:solidFill>
-                  <a:srgbClr val="1C2340"/>
-                </a:solidFill>
-                <a:latin typeface="Noto Sans JP"/>
-                <a:ea typeface="Noto Sans JP"/>
-              </a:rPr>
-              <a:t>続きは</a:t>
-            </a:r>
-          </a:p>
-        </p:txBody>
-      </p:sp>
-      <p:sp>
-        <p:nvSpPr>
-          <p:cNvPr id="5" name=""/>
-          <p:cNvSpPr txBox="1"/>
-          <p:nvPr/>
-        </p:nvSpPr>
-        <p:spPr>
-          <a:xfrm>
-            <a:off x="1181100" y="2771775"/>
-            <a:ext cx="7400925" cy="1266825"/>
-          </a:xfrm>
-          <a:prstGeom prst="rect">
-            <a:avLst/>
-          </a:prstGeom>
-          <a:noFill/>
-          <a:ln/>
-        </p:spPr>
-        <p:txBody>
-          <a:bodyPr wrap="square" lIns="0" tIns="0" rIns="0" bIns="0" anchor="ctr"/>
-          <a:lstStyle/>
-          <a:p>
-            <a:pPr/>
-            <a:r>
-              <a:rPr sz="6900" b="1">
-                <a:solidFill>
-                  <a:srgbClr val="1C2340"/>
-                </a:solidFill>
-                <a:latin typeface="Noto Sans JP"/>
-                <a:ea typeface="Noto Sans JP"/>
-              </a:rPr>
-              <a:t>次回の動画で！</a:t>
-            </a:r>
-          </a:p>
-        </p:txBody>
-      </p:sp>
-      <p:sp>
-        <p:nvSpPr>
-          <p:cNvPr id="6" name=""/>
-          <p:cNvSpPr txBox="1"/>
-          <p:nvPr/>
-        </p:nvSpPr>
-        <p:spPr>
-          <a:xfrm>
-            <a:off x="1181100" y="4105275"/>
-            <a:ext cx="5886450" cy="438150"/>
-          </a:xfrm>
-          <a:prstGeom prst="rect">
-            <a:avLst/>
-          </a:prstGeom>
-          <a:noFill/>
-          <a:ln/>
-        </p:spPr>
-        <p:txBody>
-          <a:bodyPr wrap="square" lIns="0" tIns="0" rIns="0" bIns="0" anchor="ctr"/>
-          <a:lstStyle/>
-          <a:p>
-            <a:pPr/>
-            <a:r>
-              <a:rPr sz="2400" b="1">
-                <a:solidFill>
-                  <a:srgbClr val="1C2340"/>
-                </a:solidFill>
-                <a:latin typeface="Noto Sans JP"/>
-                <a:ea typeface="Noto Sans JP"/>
-              </a:rPr>
-              <a:t>数えられる名詞 / 数えられない名詞</a:t>
-            </a:r>
-          </a:p>
-        </p:txBody>
-      </p:sp>
-      <p:sp>
-        <p:nvSpPr>
-          <p:cNvPr id="7" name=""/>
-          <p:cNvSpPr txBox="1"/>
-          <p:nvPr/>
-        </p:nvSpPr>
-        <p:spPr>
-          <a:xfrm>
-            <a:off x="1181100" y="4829175"/>
-            <a:ext cx="4838700" cy="571500"/>
-          </a:xfrm>
-          <a:prstGeom prst="rect">
-            <a:avLst/>
-          </a:prstGeom>
-          <a:noFill/>
-          <a:ln/>
-        </p:spPr>
-        <p:txBody>
-          <a:bodyPr wrap="square" lIns="0" tIns="0" rIns="0" bIns="0" anchor="ctr"/>
-          <a:lstStyle/>
-          <a:p>
-            <a:pPr/>
-            <a:r>
-              <a:rPr sz="3600" b="1">
-                <a:solidFill>
-                  <a:srgbClr val="C8401A"/>
-                </a:solidFill>
-                <a:latin typeface="Caveat"/>
-                <a:ea typeface="Caveat"/>
-              </a:rPr>
-              <a:t>Small steps, big changes.</a:t>
-            </a:r>
-          </a:p>
-        </p:txBody>
-      </p:sp>
-      <p:pic>
-        <p:nvPicPr>
-          <p:cNvPr id="8" name="Image 0" descr="/home/user/hina-english/matome/a-the/img/tile.png">    </p:cNvPr>
-          <p:cNvPicPr>
-            <a:picLocks noChangeAspect="1"/>
-          </p:cNvPicPr>
-          <p:nvPr/>
-        </p:nvPicPr>
-        <p:blipFill>
-          <a:blip r:embed="rId1"/>
-          <a:stretch>
-            <a:fillRect/>
-          </a:stretch>
-        </p:blipFill>
-        <p:spPr>
-          <a:xfrm>
-            <a:off x="7924800" y="1809750"/>
-            <a:ext cx="3238500" cy="3238500"/>
-          </a:xfrm>
-          <a:prstGeom prst="rect">
-            <a:avLst/>
-          </a:prstGeom>
-        </p:spPr>
-      </p:pic>
-    </p:spTree>
-  </p:cSld>
-  <p:clrMapOvr>
-    <a:masterClrMapping/>
-  </p:clrMapOvr>
-</p:sld>
-</file>
-
 <file path=ppt/slides/slide2.xml><?xml version="1.0" encoding="utf-8"?>
 <p:sld xmlns:a="http://schemas.openxmlformats.org/drawingml/2006/main" xmlns:r="http://schemas.openxmlformats.org/officeDocument/2006/relationships" xmlns:p="http://schemas.openxmlformats.org/presentationml/2006/main">
   <p:cSld name="Slide 2">

</xml_diff>

<commit_message>
Apply feedback on the 冠詞 Part 1 slides
- 5: "よく使う場面" now lists two cases: 「1つ」のとき and 一般的なものを
  指しているとき（特定のものを話しているわけではない）.
- 7: the a column is a book / a dog / a pencil (new pencil drawing).
- 8: the answers are back to "a university" and "an hour".
- 9: adds "an apple" (any one apple) vs "the apple" (the green one you
  point at); its two "when to use the" points move to slide 10.
- 10: those points now read ① 特定のものを指しているとき and
  ② 話し手と聞き手が同じものを認識できているとき, above the examples.
- 11/12 and 14/15: the Japanese translation sits inside the question
  card in a larger size, on both the question and the answer page.
- 13: the a / an header reads 特定のものではない、一般的なもの「1つ」.

Co-Authored-By: Claude Opus 5.5 <noreply@anthropic.com>
Claude-Session: https://claude.ai/code/session_01AdzV2rtokspoPMcfpFKx4K
</commit_message>
<xml_diff>
--- a/matome/a-the/a-the-slides.pptx
+++ b/matome/a-the/a-the-slides.pptx
@@ -621,7 +621,7 @@
       </p:sp>
       <p:pic>
         <p:nvPicPr>
-          <p:cNvPr id="6" name="Image 0" descr="/home/user/hina-english/matome/a-the/img/tile.png">    </p:cNvPr>
+          <p:cNvPr id="6" name="Image 0" descr="/home/user/hina-english/matome/img/tile.png">    </p:cNvPr>
           <p:cNvPicPr>
             <a:picLocks noChangeAspect="1"/>
           </p:cNvPicPr>
@@ -844,12 +844,12 @@
         </p:nvSpPr>
         <p:spPr>
           <a:xfrm>
-            <a:off x="685800" y="2028825"/>
-            <a:ext cx="10820400" cy="1371600"/>
+            <a:off x="685800" y="1990725"/>
+            <a:ext cx="5314950" cy="952500"/>
           </a:xfrm>
           <a:prstGeom prst="roundRect">
             <a:avLst>
-              <a:gd name="adj" fmla="val 19444"/>
+              <a:gd name="adj" fmla="val 28000"/>
             </a:avLst>
           </a:prstGeom>
           <a:solidFill>
@@ -865,9 +865,304 @@
           </a:effectLst>
         </p:spPr>
       </p:sp>
+      <p:sp>
+        <p:nvSpPr>
+          <p:cNvPr id="7" name=""/>
+          <p:cNvSpPr/>
+          <p:nvPr/>
+        </p:nvSpPr>
+        <p:spPr>
+          <a:xfrm>
+            <a:off x="914400" y="2286000"/>
+            <a:ext cx="361950" cy="361950"/>
+          </a:xfrm>
+          <a:prstGeom prst="ellipse">
+            <a:avLst/>
+          </a:prstGeom>
+          <a:solidFill>
+            <a:srgbClr val="2F86CF"/>
+          </a:solidFill>
+          <a:ln/>
+        </p:spPr>
+      </p:sp>
+      <p:sp>
+        <p:nvSpPr>
+          <p:cNvPr id="8" name=""/>
+          <p:cNvSpPr txBox="1"/>
+          <p:nvPr/>
+        </p:nvSpPr>
+        <p:spPr>
+          <a:xfrm>
+            <a:off x="885825" y="2352675"/>
+            <a:ext cx="419100" cy="238125"/>
+          </a:xfrm>
+          <a:prstGeom prst="rect">
+            <a:avLst/>
+          </a:prstGeom>
+          <a:noFill/>
+          <a:ln/>
+        </p:spPr>
+        <p:txBody>
+          <a:bodyPr wrap="square" lIns="0" tIns="0" rIns="0" bIns="0" anchor="ctr"/>
+          <a:lstStyle/>
+          <a:p>
+            <a:pPr algn="ctr"/>
+            <a:r>
+              <a:rPr sz="1450" b="1">
+                <a:solidFill>
+                  <a:srgbClr val="FFFFFF"/>
+                </a:solidFill>
+                <a:latin typeface="DM Sans"/>
+                <a:ea typeface="DM Sans"/>
+              </a:rPr>
+              <a:t>1</a:t>
+            </a:r>
+          </a:p>
+        </p:txBody>
+      </p:sp>
+      <p:sp>
+        <p:nvSpPr>
+          <p:cNvPr id="9" name=""/>
+          <p:cNvSpPr txBox="1"/>
+          <p:nvPr/>
+        </p:nvSpPr>
+        <p:spPr>
+          <a:xfrm>
+            <a:off x="1409700" y="2314575"/>
+            <a:ext cx="3467100" cy="304800"/>
+          </a:xfrm>
+          <a:prstGeom prst="rect">
+            <a:avLst/>
+          </a:prstGeom>
+          <a:noFill/>
+          <a:ln/>
+        </p:spPr>
+        <p:txBody>
+          <a:bodyPr wrap="square" lIns="0" tIns="0" rIns="0" bIns="0" anchor="ctr"/>
+          <a:lstStyle/>
+          <a:p>
+            <a:pPr/>
+            <a:r>
+              <a:rPr sz="1650" b="1">
+                <a:solidFill>
+                  <a:srgbClr val="1C2340"/>
+                </a:solidFill>
+                <a:latin typeface="Noto Sans JP"/>
+                <a:ea typeface="Noto Sans JP"/>
+              </a:rPr>
+              <a:t>特定のもの</a:t>
+            </a:r>
+            <a:pPr/>
+            <a:r>
+              <a:rPr sz="1650">
+                <a:solidFill>
+                  <a:srgbClr val="1C2340"/>
+                </a:solidFill>
+                <a:latin typeface="Noto Sans JP"/>
+                <a:ea typeface="Noto Sans JP"/>
+              </a:rPr>
+              <a:t>を指しているとき</a:t>
+            </a:r>
+          </a:p>
+        </p:txBody>
+      </p:sp>
+      <p:sp>
+        <p:nvSpPr>
+          <p:cNvPr id="10" name=""/>
+          <p:cNvSpPr/>
+          <p:nvPr/>
+        </p:nvSpPr>
+        <p:spPr>
+          <a:xfrm>
+            <a:off x="6191250" y="1990725"/>
+            <a:ext cx="5314950" cy="952500"/>
+          </a:xfrm>
+          <a:prstGeom prst="roundRect">
+            <a:avLst>
+              <a:gd name="adj" fmla="val 28000"/>
+            </a:avLst>
+          </a:prstGeom>
+          <a:solidFill>
+            <a:srgbClr val="FFFFFF"/>
+          </a:solidFill>
+          <a:ln/>
+          <a:effectLst>
+            <a:outerShdw sx="100000" sy="100000" kx="0" ky="0" algn="bl" rotWithShape="0" blurRad="152400" dist="50800" dir="5400000">
+              <a:srgbClr val="22304A">
+                <a:alpha val="10000"/>
+              </a:srgbClr>
+            </a:outerShdw>
+          </a:effectLst>
+        </p:spPr>
+      </p:sp>
+      <p:sp>
+        <p:nvSpPr>
+          <p:cNvPr id="11" name=""/>
+          <p:cNvSpPr/>
+          <p:nvPr/>
+        </p:nvSpPr>
+        <p:spPr>
+          <a:xfrm>
+            <a:off x="6419850" y="2286000"/>
+            <a:ext cx="361950" cy="361950"/>
+          </a:xfrm>
+          <a:prstGeom prst="ellipse">
+            <a:avLst/>
+          </a:prstGeom>
+          <a:solidFill>
+            <a:srgbClr val="2F86CF"/>
+          </a:solidFill>
+          <a:ln/>
+        </p:spPr>
+      </p:sp>
+      <p:sp>
+        <p:nvSpPr>
+          <p:cNvPr id="12" name=""/>
+          <p:cNvSpPr txBox="1"/>
+          <p:nvPr/>
+        </p:nvSpPr>
+        <p:spPr>
+          <a:xfrm>
+            <a:off x="6372225" y="2352675"/>
+            <a:ext cx="466725" cy="238125"/>
+          </a:xfrm>
+          <a:prstGeom prst="rect">
+            <a:avLst/>
+          </a:prstGeom>
+          <a:noFill/>
+          <a:ln/>
+        </p:spPr>
+        <p:txBody>
+          <a:bodyPr wrap="square" lIns="0" tIns="0" rIns="0" bIns="0" anchor="ctr"/>
+          <a:lstStyle/>
+          <a:p>
+            <a:pPr algn="ctr"/>
+            <a:r>
+              <a:rPr sz="1450" b="1">
+                <a:solidFill>
+                  <a:srgbClr val="FFFFFF"/>
+                </a:solidFill>
+                <a:latin typeface="DM Sans"/>
+                <a:ea typeface="DM Sans"/>
+              </a:rPr>
+              <a:t>2</a:t>
+            </a:r>
+          </a:p>
+        </p:txBody>
+      </p:sp>
+      <p:sp>
+        <p:nvSpPr>
+          <p:cNvPr id="13" name=""/>
+          <p:cNvSpPr txBox="1"/>
+          <p:nvPr/>
+        </p:nvSpPr>
+        <p:spPr>
+          <a:xfrm>
+            <a:off x="6915150" y="2162175"/>
+            <a:ext cx="2266950" cy="304800"/>
+          </a:xfrm>
+          <a:prstGeom prst="rect">
+            <a:avLst/>
+          </a:prstGeom>
+          <a:noFill/>
+          <a:ln/>
+        </p:spPr>
+        <p:txBody>
+          <a:bodyPr wrap="square" lIns="0" tIns="0" rIns="0" bIns="0" anchor="ctr"/>
+          <a:lstStyle/>
+          <a:p>
+            <a:pPr/>
+            <a:r>
+              <a:rPr sz="1650">
+                <a:solidFill>
+                  <a:srgbClr val="1C2340"/>
+                </a:solidFill>
+                <a:latin typeface="Noto Sans JP"/>
+                <a:ea typeface="Noto Sans JP"/>
+              </a:rPr>
+              <a:t>話し手と聞き手が</a:t>
+            </a:r>
+          </a:p>
+        </p:txBody>
+      </p:sp>
+      <p:sp>
+        <p:nvSpPr>
+          <p:cNvPr id="14" name=""/>
+          <p:cNvSpPr txBox="1"/>
+          <p:nvPr/>
+        </p:nvSpPr>
+        <p:spPr>
+          <a:xfrm>
+            <a:off x="6915150" y="2466975"/>
+            <a:ext cx="3714750" cy="304800"/>
+          </a:xfrm>
+          <a:prstGeom prst="rect">
+            <a:avLst/>
+          </a:prstGeom>
+          <a:noFill/>
+          <a:ln/>
+        </p:spPr>
+        <p:txBody>
+          <a:bodyPr wrap="square" lIns="0" tIns="0" rIns="0" bIns="0" anchor="ctr"/>
+          <a:lstStyle/>
+          <a:p>
+            <a:pPr/>
+            <a:r>
+              <a:rPr sz="1650" b="1">
+                <a:solidFill>
+                  <a:srgbClr val="1C2340"/>
+                </a:solidFill>
+                <a:latin typeface="Noto Sans JP"/>
+                <a:ea typeface="Noto Sans JP"/>
+              </a:rPr>
+              <a:t>同じものを認識できている</a:t>
+            </a:r>
+            <a:pPr/>
+            <a:r>
+              <a:rPr sz="1650">
+                <a:solidFill>
+                  <a:srgbClr val="1C2340"/>
+                </a:solidFill>
+                <a:latin typeface="Noto Sans JP"/>
+                <a:ea typeface="Noto Sans JP"/>
+              </a:rPr>
+              <a:t>とき</a:t>
+            </a:r>
+          </a:p>
+        </p:txBody>
+      </p:sp>
+      <p:sp>
+        <p:nvSpPr>
+          <p:cNvPr id="15" name=""/>
+          <p:cNvSpPr/>
+          <p:nvPr/>
+        </p:nvSpPr>
+        <p:spPr>
+          <a:xfrm>
+            <a:off x="685800" y="3095625"/>
+            <a:ext cx="10820400" cy="1038225"/>
+          </a:xfrm>
+          <a:prstGeom prst="roundRect">
+            <a:avLst>
+              <a:gd name="adj" fmla="val 25688"/>
+            </a:avLst>
+          </a:prstGeom>
+          <a:solidFill>
+            <a:srgbClr val="FFFFFF"/>
+          </a:solidFill>
+          <a:ln/>
+          <a:effectLst>
+            <a:outerShdw sx="100000" sy="100000" kx="0" ky="0" algn="bl" rotWithShape="0" blurRad="152400" dist="50800" dir="5400000">
+              <a:srgbClr val="22304A">
+                <a:alpha val="10000"/>
+              </a:srgbClr>
+            </a:outerShdw>
+          </a:effectLst>
+        </p:spPr>
+      </p:sp>
       <p:pic>
         <p:nvPicPr>
-          <p:cNvPr id="7" name="Image 0" descr="ドア">    </p:cNvPr>
+          <p:cNvPr id="16" name="Image 0" descr="ドア">    </p:cNvPr>
           <p:cNvPicPr>
             <a:picLocks noChangeAspect="1"/>
           </p:cNvPicPr>
@@ -881,8 +1176,8 @@
         </p:blipFill>
         <p:spPr>
           <a:xfrm>
-            <a:off x="895350" y="2124075"/>
-            <a:ext cx="1181100" cy="1181100"/>
+            <a:off x="895350" y="3181350"/>
+            <a:ext cx="876300" cy="876300"/>
           </a:xfrm>
           <a:prstGeom prst="rect">
             <a:avLst/>
@@ -891,28 +1186,28 @@
       </p:pic>
       <p:sp>
         <p:nvSpPr>
-          <p:cNvPr id="8" name=""/>
-          <p:cNvSpPr txBox="1"/>
-          <p:nvPr/>
-        </p:nvSpPr>
-        <p:spPr>
-          <a:xfrm>
-            <a:off x="2324100" y="2324100"/>
-            <a:ext cx="4552950" cy="447675"/>
-          </a:xfrm>
-          <a:prstGeom prst="rect">
-            <a:avLst/>
-          </a:prstGeom>
-          <a:noFill/>
-          <a:ln/>
-        </p:spPr>
-        <p:txBody>
-          <a:bodyPr wrap="square" lIns="0" tIns="0" rIns="0" bIns="0" anchor="ctr"/>
-          <a:lstStyle/>
-          <a:p>
-            <a:pPr/>
-            <a:r>
-              <a:rPr sz="2700" b="1">
+          <p:cNvPr id="17" name=""/>
+          <p:cNvSpPr txBox="1"/>
+          <p:nvPr/>
+        </p:nvSpPr>
+        <p:spPr>
+          <a:xfrm>
+            <a:off x="2019300" y="3248025"/>
+            <a:ext cx="4038600" cy="400050"/>
+          </a:xfrm>
+          <a:prstGeom prst="rect">
+            <a:avLst/>
+          </a:prstGeom>
+          <a:noFill/>
+          <a:ln/>
+        </p:spPr>
+        <p:txBody>
+          <a:bodyPr wrap="square" lIns="0" tIns="0" rIns="0" bIns="0" anchor="ctr"/>
+          <a:lstStyle/>
+          <a:p>
+            <a:pPr/>
+            <a:r>
+              <a:rPr sz="2400" b="1">
                 <a:solidFill>
                   <a:srgbClr val="1C2340"/>
                 </a:solidFill>
@@ -923,7 +1218,7 @@
             </a:r>
             <a:pPr/>
             <a:r>
-              <a:rPr sz="2700" b="1">
+              <a:rPr sz="2400" b="1">
                 <a:solidFill>
                   <a:srgbClr val="2F86CF"/>
                 </a:solidFill>
@@ -934,7 +1229,7 @@
             </a:r>
             <a:pPr/>
             <a:r>
-              <a:rPr sz="2700" b="1">
+              <a:rPr sz="2400" b="1">
                 <a:solidFill>
                   <a:srgbClr val="1C2340"/>
                 </a:solidFill>
@@ -948,13 +1243,13 @@
       </p:sp>
       <p:sp>
         <p:nvSpPr>
-          <p:cNvPr id="9" name=""/>
-          <p:cNvSpPr txBox="1"/>
-          <p:nvPr/>
-        </p:nvSpPr>
-        <p:spPr>
-          <a:xfrm>
-            <a:off x="2324100" y="2828925"/>
+          <p:cNvPr id="18" name=""/>
+          <p:cNvSpPr txBox="1"/>
+          <p:nvPr/>
+        </p:nvSpPr>
+        <p:spPr>
+          <a:xfrm>
+            <a:off x="2019300" y="3705225"/>
             <a:ext cx="3181350" cy="276225"/>
           </a:xfrm>
           <a:prstGeom prst="rect">
@@ -983,13 +1278,13 @@
       </p:sp>
       <p:sp>
         <p:nvSpPr>
-          <p:cNvPr id="10" name=""/>
+          <p:cNvPr id="19" name=""/>
           <p:cNvSpPr/>
           <p:nvPr/>
         </p:nvSpPr>
         <p:spPr>
           <a:xfrm>
-            <a:off x="7981950" y="2305050"/>
+            <a:off x="7981950" y="3200400"/>
             <a:ext cx="3238500" cy="828675"/>
           </a:xfrm>
           <a:prstGeom prst="roundRect">
@@ -1005,13 +1300,13 @@
       </p:sp>
       <p:sp>
         <p:nvSpPr>
-          <p:cNvPr id="11" name=""/>
-          <p:cNvSpPr txBox="1"/>
-          <p:nvPr/>
-        </p:nvSpPr>
-        <p:spPr>
-          <a:xfrm>
-            <a:off x="8172450" y="2447925"/>
+          <p:cNvPr id="20" name=""/>
+          <p:cNvSpPr txBox="1"/>
+          <p:nvPr/>
+        </p:nvSpPr>
+        <p:spPr>
+          <a:xfrm>
+            <a:off x="8172450" y="3343275"/>
             <a:ext cx="2428875" cy="257175"/>
           </a:xfrm>
           <a:prstGeom prst="rect">
@@ -1040,13 +1335,13 @@
       </p:sp>
       <p:sp>
         <p:nvSpPr>
-          <p:cNvPr id="12" name=""/>
-          <p:cNvSpPr txBox="1"/>
-          <p:nvPr/>
-        </p:nvSpPr>
-        <p:spPr>
-          <a:xfrm>
-            <a:off x="8172450" y="2724150"/>
+          <p:cNvPr id="21" name=""/>
+          <p:cNvSpPr txBox="1"/>
+          <p:nvPr/>
+        </p:nvSpPr>
+        <p:spPr>
+          <a:xfrm>
+            <a:off x="8172450" y="3629025"/>
             <a:ext cx="2619375" cy="257175"/>
           </a:xfrm>
           <a:prstGeom prst="rect">
@@ -1075,18 +1370,18 @@
       </p:sp>
       <p:sp>
         <p:nvSpPr>
-          <p:cNvPr id="13" name=""/>
+          <p:cNvPr id="22" name=""/>
           <p:cNvSpPr/>
           <p:nvPr/>
         </p:nvSpPr>
         <p:spPr>
           <a:xfrm>
-            <a:off x="685800" y="3552825"/>
-            <a:ext cx="10820400" cy="1371600"/>
+            <a:off x="685800" y="4248150"/>
+            <a:ext cx="10820400" cy="1038225"/>
           </a:xfrm>
           <a:prstGeom prst="roundRect">
             <a:avLst>
-              <a:gd name="adj" fmla="val 19444"/>
+              <a:gd name="adj" fmla="val 25688"/>
             </a:avLst>
           </a:prstGeom>
           <a:solidFill>
@@ -1104,7 +1399,7 @@
       </p:sp>
       <p:pic>
         <p:nvPicPr>
-          <p:cNvPr id="14" name="Image 1" descr="トイレ">    </p:cNvPr>
+          <p:cNvPr id="23" name="Image 1" descr="トイレ">    </p:cNvPr>
           <p:cNvPicPr>
             <a:picLocks noChangeAspect="1"/>
           </p:cNvPicPr>
@@ -1118,8 +1413,8 @@
         </p:blipFill>
         <p:spPr>
           <a:xfrm>
-            <a:off x="895350" y="3648075"/>
-            <a:ext cx="1181100" cy="1181100"/>
+            <a:off x="895350" y="4333875"/>
+            <a:ext cx="876300" cy="876300"/>
           </a:xfrm>
           <a:prstGeom prst="rect">
             <a:avLst/>
@@ -1128,28 +1423,28 @@
       </p:pic>
       <p:sp>
         <p:nvSpPr>
-          <p:cNvPr id="15" name=""/>
-          <p:cNvSpPr txBox="1"/>
-          <p:nvPr/>
-        </p:nvSpPr>
-        <p:spPr>
-          <a:xfrm>
-            <a:off x="2324100" y="3848100"/>
-            <a:ext cx="4962525" cy="447675"/>
-          </a:xfrm>
-          <a:prstGeom prst="rect">
-            <a:avLst/>
-          </a:prstGeom>
-          <a:noFill/>
-          <a:ln/>
-        </p:spPr>
-        <p:txBody>
-          <a:bodyPr wrap="square" lIns="0" tIns="0" rIns="0" bIns="0" anchor="ctr"/>
-          <a:lstStyle/>
-          <a:p>
-            <a:pPr/>
-            <a:r>
-              <a:rPr sz="2700" b="1">
+          <p:cNvPr id="24" name=""/>
+          <p:cNvSpPr txBox="1"/>
+          <p:nvPr/>
+        </p:nvSpPr>
+        <p:spPr>
+          <a:xfrm>
+            <a:off x="2019300" y="4400550"/>
+            <a:ext cx="4457700" cy="400050"/>
+          </a:xfrm>
+          <a:prstGeom prst="rect">
+            <a:avLst/>
+          </a:prstGeom>
+          <a:noFill/>
+          <a:ln/>
+        </p:spPr>
+        <p:txBody>
+          <a:bodyPr wrap="square" lIns="0" tIns="0" rIns="0" bIns="0" anchor="ctr"/>
+          <a:lstStyle/>
+          <a:p>
+            <a:pPr/>
+            <a:r>
+              <a:rPr sz="2400" b="1">
                 <a:solidFill>
                   <a:srgbClr val="1C2340"/>
                 </a:solidFill>
@@ -1160,7 +1455,7 @@
             </a:r>
             <a:pPr/>
             <a:r>
-              <a:rPr sz="2700" b="1">
+              <a:rPr sz="2400" b="1">
                 <a:solidFill>
                   <a:srgbClr val="2F86CF"/>
                 </a:solidFill>
@@ -1171,7 +1466,7 @@
             </a:r>
             <a:pPr/>
             <a:r>
-              <a:rPr sz="2700" b="1">
+              <a:rPr sz="2400" b="1">
                 <a:solidFill>
                   <a:srgbClr val="1C2340"/>
                 </a:solidFill>
@@ -1185,13 +1480,13 @@
       </p:sp>
       <p:sp>
         <p:nvSpPr>
-          <p:cNvPr id="16" name=""/>
-          <p:cNvSpPr txBox="1"/>
-          <p:nvPr/>
-        </p:nvSpPr>
-        <p:spPr>
-          <a:xfrm>
-            <a:off x="2324100" y="4352925"/>
+          <p:cNvPr id="25" name=""/>
+          <p:cNvSpPr txBox="1"/>
+          <p:nvPr/>
+        </p:nvSpPr>
+        <p:spPr>
+          <a:xfrm>
+            <a:off x="2019300" y="4857750"/>
             <a:ext cx="2524125" cy="276225"/>
           </a:xfrm>
           <a:prstGeom prst="rect">
@@ -1220,13 +1515,13 @@
       </p:sp>
       <p:sp>
         <p:nvSpPr>
-          <p:cNvPr id="17" name=""/>
+          <p:cNvPr id="26" name=""/>
           <p:cNvSpPr/>
           <p:nvPr/>
         </p:nvSpPr>
         <p:spPr>
           <a:xfrm>
-            <a:off x="7981950" y="3819525"/>
+            <a:off x="7981950" y="4352925"/>
             <a:ext cx="3238500" cy="828675"/>
           </a:xfrm>
           <a:prstGeom prst="roundRect">
@@ -1242,13 +1537,13 @@
       </p:sp>
       <p:sp>
         <p:nvSpPr>
-          <p:cNvPr id="18" name=""/>
-          <p:cNvSpPr txBox="1"/>
-          <p:nvPr/>
-        </p:nvSpPr>
-        <p:spPr>
-          <a:xfrm>
-            <a:off x="8172450" y="3962400"/>
+          <p:cNvPr id="27" name=""/>
+          <p:cNvSpPr txBox="1"/>
+          <p:nvPr/>
+        </p:nvSpPr>
+        <p:spPr>
+          <a:xfrm>
+            <a:off x="8172450" y="4495800"/>
             <a:ext cx="2628900" cy="257175"/>
           </a:xfrm>
           <a:prstGeom prst="rect">
@@ -1277,13 +1572,13 @@
       </p:sp>
       <p:sp>
         <p:nvSpPr>
-          <p:cNvPr id="19" name=""/>
-          <p:cNvSpPr txBox="1"/>
-          <p:nvPr/>
-        </p:nvSpPr>
-        <p:spPr>
-          <a:xfrm>
-            <a:off x="8172450" y="4248150"/>
+          <p:cNvPr id="28" name=""/>
+          <p:cNvSpPr txBox="1"/>
+          <p:nvPr/>
+        </p:nvSpPr>
+        <p:spPr>
+          <a:xfrm>
+            <a:off x="8172450" y="4781550"/>
             <a:ext cx="1371600" cy="257175"/>
           </a:xfrm>
           <a:prstGeom prst="rect">
@@ -1312,18 +1607,18 @@
       </p:sp>
       <p:sp>
         <p:nvSpPr>
-          <p:cNvPr id="20" name=""/>
+          <p:cNvPr id="29" name=""/>
           <p:cNvSpPr/>
           <p:nvPr/>
         </p:nvSpPr>
         <p:spPr>
           <a:xfrm>
-            <a:off x="685800" y="5067300"/>
-            <a:ext cx="10820400" cy="1371600"/>
+            <a:off x="685800" y="5400675"/>
+            <a:ext cx="10820400" cy="1038225"/>
           </a:xfrm>
           <a:prstGeom prst="roundRect">
             <a:avLst>
-              <a:gd name="adj" fmla="val 19444"/>
+              <a:gd name="adj" fmla="val 25688"/>
             </a:avLst>
           </a:prstGeom>
           <a:solidFill>
@@ -1341,7 +1636,7 @@
       </p:sp>
       <p:pic>
         <p:nvPicPr>
-          <p:cNvPr id="21" name="Image 2" descr="太陽">    </p:cNvPr>
+          <p:cNvPr id="30" name="Image 2" descr="太陽">    </p:cNvPr>
           <p:cNvPicPr>
             <a:picLocks noChangeAspect="1"/>
           </p:cNvPicPr>
@@ -1355,8 +1650,8 @@
         </p:blipFill>
         <p:spPr>
           <a:xfrm>
-            <a:off x="895350" y="5162550"/>
-            <a:ext cx="1181100" cy="1181100"/>
+            <a:off x="895350" y="5486400"/>
+            <a:ext cx="876300" cy="876300"/>
           </a:xfrm>
           <a:prstGeom prst="rect">
             <a:avLst/>
@@ -1365,28 +1660,28 @@
       </p:pic>
       <p:sp>
         <p:nvSpPr>
-          <p:cNvPr id="22" name=""/>
-          <p:cNvSpPr txBox="1"/>
-          <p:nvPr/>
-        </p:nvSpPr>
-        <p:spPr>
-          <a:xfrm>
-            <a:off x="2324100" y="5362575"/>
-            <a:ext cx="4772025" cy="447675"/>
-          </a:xfrm>
-          <a:prstGeom prst="rect">
-            <a:avLst/>
-          </a:prstGeom>
-          <a:noFill/>
-          <a:ln/>
-        </p:spPr>
-        <p:txBody>
-          <a:bodyPr wrap="square" lIns="0" tIns="0" rIns="0" bIns="0" anchor="ctr"/>
-          <a:lstStyle/>
-          <a:p>
-            <a:pPr/>
-            <a:r>
-              <a:rPr sz="2700" b="1">
+          <p:cNvPr id="31" name=""/>
+          <p:cNvSpPr txBox="1"/>
+          <p:nvPr/>
+        </p:nvSpPr>
+        <p:spPr>
+          <a:xfrm>
+            <a:off x="2019300" y="5553075"/>
+            <a:ext cx="4305300" cy="400050"/>
+          </a:xfrm>
+          <a:prstGeom prst="rect">
+            <a:avLst/>
+          </a:prstGeom>
+          <a:noFill/>
+          <a:ln/>
+        </p:spPr>
+        <p:txBody>
+          <a:bodyPr wrap="square" lIns="0" tIns="0" rIns="0" bIns="0" anchor="ctr"/>
+          <a:lstStyle/>
+          <a:p>
+            <a:pPr/>
+            <a:r>
+              <a:rPr sz="2400" b="1">
                 <a:solidFill>
                   <a:srgbClr val="2F86CF"/>
                 </a:solidFill>
@@ -1397,7 +1692,7 @@
             </a:r>
             <a:pPr/>
             <a:r>
-              <a:rPr sz="2700" b="1">
+              <a:rPr sz="2400" b="1">
                 <a:solidFill>
                   <a:srgbClr val="1C2340"/>
                 </a:solidFill>
@@ -1411,13 +1706,13 @@
       </p:sp>
       <p:sp>
         <p:nvSpPr>
-          <p:cNvPr id="23" name=""/>
-          <p:cNvSpPr txBox="1"/>
-          <p:nvPr/>
-        </p:nvSpPr>
-        <p:spPr>
-          <a:xfrm>
-            <a:off x="2324100" y="5867400"/>
+          <p:cNvPr id="32" name=""/>
+          <p:cNvSpPr txBox="1"/>
+          <p:nvPr/>
+        </p:nvSpPr>
+        <p:spPr>
+          <a:xfrm>
+            <a:off x="2019300" y="6010275"/>
             <a:ext cx="3162300" cy="276225"/>
           </a:xfrm>
           <a:prstGeom prst="rect">
@@ -1446,13 +1741,13 @@
       </p:sp>
       <p:sp>
         <p:nvSpPr>
-          <p:cNvPr id="24" name=""/>
+          <p:cNvPr id="33" name=""/>
           <p:cNvSpPr/>
           <p:nvPr/>
         </p:nvSpPr>
         <p:spPr>
           <a:xfrm>
-            <a:off x="7981950" y="5343525"/>
+            <a:off x="7981950" y="5505450"/>
             <a:ext cx="3238500" cy="828675"/>
           </a:xfrm>
           <a:prstGeom prst="roundRect">
@@ -1468,13 +1763,13 @@
       </p:sp>
       <p:sp>
         <p:nvSpPr>
-          <p:cNvPr id="25" name=""/>
-          <p:cNvSpPr txBox="1"/>
-          <p:nvPr/>
-        </p:nvSpPr>
-        <p:spPr>
-          <a:xfrm>
-            <a:off x="8172450" y="5486400"/>
+          <p:cNvPr id="34" name=""/>
+          <p:cNvSpPr txBox="1"/>
+          <p:nvPr/>
+        </p:nvSpPr>
+        <p:spPr>
+          <a:xfrm>
+            <a:off x="8172450" y="5648325"/>
             <a:ext cx="2428875" cy="257175"/>
           </a:xfrm>
           <a:prstGeom prst="rect">
@@ -1503,13 +1798,13 @@
       </p:sp>
       <p:sp>
         <p:nvSpPr>
-          <p:cNvPr id="26" name=""/>
-          <p:cNvSpPr txBox="1"/>
-          <p:nvPr/>
-        </p:nvSpPr>
-        <p:spPr>
-          <a:xfrm>
-            <a:off x="8172450" y="5762625"/>
+          <p:cNvPr id="35" name=""/>
+          <p:cNvSpPr txBox="1"/>
+          <p:nvPr/>
+        </p:nvSpPr>
+        <p:spPr>
+          <a:xfrm>
+            <a:off x="8172450" y="5934075"/>
             <a:ext cx="1381125" cy="257175"/>
           </a:xfrm>
           <a:prstGeom prst="rect">
@@ -1823,7 +2118,7 @@
         </p:nvSpPr>
         <p:spPr>
           <a:xfrm>
-            <a:off x="3162300" y="2667000"/>
+            <a:off x="3162300" y="2457450"/>
             <a:ext cx="2362200" cy="571500"/>
           </a:xfrm>
           <a:prstGeom prst="rect">
@@ -1858,7 +2153,7 @@
         </p:nvSpPr>
         <p:spPr>
           <a:xfrm>
-            <a:off x="5067300" y="2590800"/>
+            <a:off x="5067300" y="2381250"/>
             <a:ext cx="1333500" cy="723900"/>
           </a:xfrm>
           <a:prstGeom prst="roundRect">
@@ -1885,7 +2180,7 @@
         </p:nvSpPr>
         <p:spPr>
           <a:xfrm>
-            <a:off x="6553200" y="2667000"/>
+            <a:off x="6553200" y="2457450"/>
             <a:ext cx="1381125" cy="571500"/>
           </a:xfrm>
           <a:prstGeom prst="rect">
@@ -1920,7 +2215,7 @@
         </p:nvSpPr>
         <p:spPr>
           <a:xfrm>
-            <a:off x="3162300" y="3600450"/>
+            <a:off x="3162300" y="3314700"/>
             <a:ext cx="1333500" cy="723900"/>
           </a:xfrm>
           <a:prstGeom prst="roundRect">
@@ -1947,7 +2242,7 @@
         </p:nvSpPr>
         <p:spPr>
           <a:xfrm>
-            <a:off x="4648200" y="3676650"/>
+            <a:off x="4648200" y="3390900"/>
             <a:ext cx="5076825" cy="571500"/>
           </a:xfrm>
           <a:prstGeom prst="rect">
@@ -1977,6 +2272,41 @@
       <p:sp>
         <p:nvSpPr>
           <p:cNvPr id="13" name=""/>
+          <p:cNvSpPr txBox="1"/>
+          <p:nvPr/>
+        </p:nvSpPr>
+        <p:spPr>
+          <a:xfrm>
+            <a:off x="3162300" y="4229100"/>
+            <a:ext cx="7429500" cy="352425"/>
+          </a:xfrm>
+          <a:prstGeom prst="rect">
+            <a:avLst/>
+          </a:prstGeom>
+          <a:noFill/>
+          <a:ln/>
+        </p:spPr>
+        <p:txBody>
+          <a:bodyPr wrap="square" lIns="0" tIns="0" rIns="0" bIns="0" anchor="ctr"/>
+          <a:lstStyle/>
+          <a:p>
+            <a:pPr/>
+            <a:r>
+              <a:rPr sz="1950" b="1">
+                <a:solidFill>
+                  <a:srgbClr val="4A5270"/>
+                </a:solidFill>
+                <a:latin typeface="Noto Sans JP"/>
+                <a:ea typeface="Noto Sans JP"/>
+              </a:rPr>
+              <a:t>私はバッグを買いました。そのバッグは高かったです。</a:t>
+            </a:r>
+          </a:p>
+        </p:txBody>
+      </p:sp>
+      <p:sp>
+        <p:nvSpPr>
+          <p:cNvPr id="14" name=""/>
           <p:cNvSpPr/>
           <p:nvPr/>
         </p:nvSpPr>
@@ -1998,7 +2328,7 @@
       </p:sp>
       <p:sp>
         <p:nvSpPr>
-          <p:cNvPr id="14" name=""/>
+          <p:cNvPr id="15" name=""/>
           <p:cNvSpPr txBox="1"/>
           <p:nvPr/>
         </p:nvSpPr>
@@ -2033,7 +2363,7 @@
       </p:sp>
       <p:sp>
         <p:nvSpPr>
-          <p:cNvPr id="15" name=""/>
+          <p:cNvPr id="16" name=""/>
           <p:cNvSpPr txBox="1"/>
           <p:nvPr/>
         </p:nvSpPr>
@@ -2068,7 +2398,7 @@
       </p:sp>
       <p:sp>
         <p:nvSpPr>
-          <p:cNvPr id="16" name=""/>
+          <p:cNvPr id="17" name=""/>
           <p:cNvSpPr/>
           <p:nvPr/>
         </p:nvSpPr>
@@ -2090,7 +2420,7 @@
       </p:sp>
       <p:sp>
         <p:nvSpPr>
-          <p:cNvPr id="17" name=""/>
+          <p:cNvPr id="18" name=""/>
           <p:cNvSpPr txBox="1"/>
           <p:nvPr/>
         </p:nvSpPr>
@@ -2125,7 +2455,7 @@
       </p:sp>
       <p:sp>
         <p:nvSpPr>
-          <p:cNvPr id="18" name=""/>
+          <p:cNvPr id="19" name=""/>
           <p:cNvSpPr txBox="1"/>
           <p:nvPr/>
         </p:nvSpPr>
@@ -2445,7 +2775,7 @@
         </p:nvSpPr>
         <p:spPr>
           <a:xfrm>
-            <a:off x="3162300" y="2667000"/>
+            <a:off x="3162300" y="2457450"/>
             <a:ext cx="2362200" cy="571500"/>
           </a:xfrm>
           <a:prstGeom prst="rect">
@@ -2480,7 +2810,7 @@
         </p:nvSpPr>
         <p:spPr>
           <a:xfrm>
-            <a:off x="5067300" y="2590800"/>
+            <a:off x="5067300" y="2381250"/>
             <a:ext cx="1333500" cy="723900"/>
           </a:xfrm>
           <a:prstGeom prst="roundRect">
@@ -2502,7 +2832,7 @@
         </p:nvSpPr>
         <p:spPr>
           <a:xfrm>
-            <a:off x="5419725" y="2676525"/>
+            <a:off x="5419725" y="2466975"/>
             <a:ext cx="628650" cy="552450"/>
           </a:xfrm>
           <a:prstGeom prst="rect">
@@ -2537,7 +2867,7 @@
         </p:nvSpPr>
         <p:spPr>
           <a:xfrm>
-            <a:off x="6553200" y="2667000"/>
+            <a:off x="6553200" y="2457450"/>
             <a:ext cx="1381125" cy="571500"/>
           </a:xfrm>
           <a:prstGeom prst="rect">
@@ -2572,7 +2902,7 @@
         </p:nvSpPr>
         <p:spPr>
           <a:xfrm>
-            <a:off x="3162300" y="3600450"/>
+            <a:off x="3162300" y="3314700"/>
             <a:ext cx="1333500" cy="723900"/>
           </a:xfrm>
           <a:prstGeom prst="roundRect">
@@ -2594,7 +2924,7 @@
         </p:nvSpPr>
         <p:spPr>
           <a:xfrm>
-            <a:off x="3219450" y="3686175"/>
+            <a:off x="3219450" y="3400425"/>
             <a:ext cx="1219200" cy="552450"/>
           </a:xfrm>
           <a:prstGeom prst="rect">
@@ -2629,7 +2959,7 @@
         </p:nvSpPr>
         <p:spPr>
           <a:xfrm>
-            <a:off x="4648200" y="3676650"/>
+            <a:off x="4648200" y="3390900"/>
             <a:ext cx="5076825" cy="571500"/>
           </a:xfrm>
           <a:prstGeom prst="rect">
@@ -2659,6 +2989,41 @@
       <p:sp>
         <p:nvSpPr>
           <p:cNvPr id="15" name=""/>
+          <p:cNvSpPr txBox="1"/>
+          <p:nvPr/>
+        </p:nvSpPr>
+        <p:spPr>
+          <a:xfrm>
+            <a:off x="3162300" y="4229100"/>
+            <a:ext cx="7429500" cy="352425"/>
+          </a:xfrm>
+          <a:prstGeom prst="rect">
+            <a:avLst/>
+          </a:prstGeom>
+          <a:noFill/>
+          <a:ln/>
+        </p:spPr>
+        <p:txBody>
+          <a:bodyPr wrap="square" lIns="0" tIns="0" rIns="0" bIns="0" anchor="ctr"/>
+          <a:lstStyle/>
+          <a:p>
+            <a:pPr/>
+            <a:r>
+              <a:rPr sz="1950" b="1">
+                <a:solidFill>
+                  <a:srgbClr val="4A5270"/>
+                </a:solidFill>
+                <a:latin typeface="Noto Sans JP"/>
+                <a:ea typeface="Noto Sans JP"/>
+              </a:rPr>
+              <a:t>私はバッグを買いました。そのバッグは高かったです。</a:t>
+            </a:r>
+          </a:p>
+        </p:txBody>
+      </p:sp>
+      <p:sp>
+        <p:nvSpPr>
+          <p:cNvPr id="16" name=""/>
           <p:cNvSpPr/>
           <p:nvPr/>
         </p:nvSpPr>
@@ -2687,13 +3052,13 @@
       </p:sp>
       <p:sp>
         <p:nvSpPr>
-          <p:cNvPr id="16" name=""/>
+          <p:cNvPr id="17" name=""/>
           <p:cNvSpPr/>
           <p:nvPr/>
         </p:nvSpPr>
         <p:spPr>
           <a:xfrm>
-            <a:off x="990600" y="5210175"/>
+            <a:off x="990600" y="5391150"/>
             <a:ext cx="790575" cy="371475"/>
           </a:xfrm>
           <a:prstGeom prst="roundRect">
@@ -2709,13 +3074,13 @@
       </p:sp>
       <p:sp>
         <p:nvSpPr>
-          <p:cNvPr id="17" name=""/>
-          <p:cNvSpPr txBox="1"/>
-          <p:nvPr/>
-        </p:nvSpPr>
-        <p:spPr>
-          <a:xfrm>
-            <a:off x="1162050" y="5267325"/>
+          <p:cNvPr id="18" name=""/>
+          <p:cNvSpPr txBox="1"/>
+          <p:nvPr/>
+        </p:nvSpPr>
+        <p:spPr>
+          <a:xfrm>
+            <a:off x="1162050" y="5448300"/>
             <a:ext cx="857250" cy="247650"/>
           </a:xfrm>
           <a:prstGeom prst="rect">
@@ -2744,13 +3109,13 @@
       </p:sp>
       <p:sp>
         <p:nvSpPr>
-          <p:cNvPr id="18" name=""/>
-          <p:cNvSpPr txBox="1"/>
-          <p:nvPr/>
-        </p:nvSpPr>
-        <p:spPr>
-          <a:xfrm>
-            <a:off x="1914525" y="5229225"/>
+          <p:cNvPr id="19" name=""/>
+          <p:cNvSpPr txBox="1"/>
+          <p:nvPr/>
+        </p:nvSpPr>
+        <p:spPr>
+          <a:xfrm>
+            <a:off x="1914525" y="5410200"/>
             <a:ext cx="2981325" cy="333375"/>
           </a:xfrm>
           <a:prstGeom prst="rect">
@@ -2812,13 +3177,13 @@
       </p:sp>
       <p:sp>
         <p:nvSpPr>
-          <p:cNvPr id="19" name=""/>
+          <p:cNvPr id="20" name=""/>
           <p:cNvSpPr/>
           <p:nvPr/>
         </p:nvSpPr>
         <p:spPr>
           <a:xfrm>
-            <a:off x="990600" y="5676900"/>
+            <a:off x="990600" y="5857875"/>
             <a:ext cx="790575" cy="371475"/>
           </a:xfrm>
           <a:prstGeom prst="roundRect">
@@ -2834,13 +3199,13 @@
       </p:sp>
       <p:sp>
         <p:nvSpPr>
-          <p:cNvPr id="20" name=""/>
-          <p:cNvSpPr txBox="1"/>
-          <p:nvPr/>
-        </p:nvSpPr>
-        <p:spPr>
-          <a:xfrm>
-            <a:off x="1162050" y="5734050"/>
+          <p:cNvPr id="21" name=""/>
+          <p:cNvSpPr txBox="1"/>
+          <p:nvPr/>
+        </p:nvSpPr>
+        <p:spPr>
+          <a:xfrm>
+            <a:off x="1162050" y="5915025"/>
             <a:ext cx="857250" cy="247650"/>
           </a:xfrm>
           <a:prstGeom prst="rect">
@@ -2869,13 +3234,13 @@
       </p:sp>
       <p:sp>
         <p:nvSpPr>
-          <p:cNvPr id="21" name=""/>
-          <p:cNvSpPr txBox="1"/>
-          <p:nvPr/>
-        </p:nvSpPr>
-        <p:spPr>
-          <a:xfrm>
-            <a:off x="1914525" y="5695950"/>
+          <p:cNvPr id="22" name=""/>
+          <p:cNvSpPr txBox="1"/>
+          <p:nvPr/>
+        </p:nvSpPr>
+        <p:spPr>
+          <a:xfrm>
+            <a:off x="1914525" y="5876925"/>
             <a:ext cx="5629275" cy="333375"/>
           </a:xfrm>
           <a:prstGeom prst="rect">
@@ -2931,41 +3296,6 @@
                 <a:ea typeface="DM Sans"/>
               </a:rPr>
               <a:t>bag</a:t>
-            </a:r>
-          </a:p>
-        </p:txBody>
-      </p:sp>
-      <p:sp>
-        <p:nvSpPr>
-          <p:cNvPr id="22" name=""/>
-          <p:cNvSpPr txBox="1"/>
-          <p:nvPr/>
-        </p:nvSpPr>
-        <p:spPr>
-          <a:xfrm>
-            <a:off x="990600" y="6162675"/>
-            <a:ext cx="5524500" cy="257175"/>
-          </a:xfrm>
-          <a:prstGeom prst="rect">
-            <a:avLst/>
-          </a:prstGeom>
-          <a:noFill/>
-          <a:ln/>
-        </p:spPr>
-        <p:txBody>
-          <a:bodyPr wrap="square" lIns="0" tIns="0" rIns="0" bIns="0" anchor="ctr"/>
-          <a:lstStyle/>
-          <a:p>
-            <a:pPr/>
-            <a:r>
-              <a:rPr sz="1450">
-                <a:solidFill>
-                  <a:srgbClr val="4A5270"/>
-                </a:solidFill>
-                <a:latin typeface="Noto Sans JP"/>
-                <a:ea typeface="Noto Sans JP"/>
-              </a:rPr>
-              <a:t>私はバッグを買いました。そのバッグは高かったです。</a:t>
             </a:r>
           </a:p>
         </p:txBody>
@@ -3228,29 +3558,29 @@
         </p:nvSpPr>
         <p:spPr>
           <a:xfrm>
-            <a:off x="3219450" y="2190750"/>
-            <a:ext cx="3457575" cy="285750"/>
-          </a:xfrm>
-          <a:prstGeom prst="rect">
-            <a:avLst/>
-          </a:prstGeom>
-          <a:noFill/>
-          <a:ln/>
-        </p:spPr>
-        <p:txBody>
-          <a:bodyPr wrap="square" lIns="0" tIns="0" rIns="0" bIns="0" anchor="ctr"/>
-          <a:lstStyle/>
-          <a:p>
-            <a:pPr/>
-            <a:r>
-              <a:rPr sz="1600" b="1">
-                <a:solidFill>
-                  <a:srgbClr val="1C2340"/>
-                </a:solidFill>
-                <a:latin typeface="Noto Sans JP"/>
-                <a:ea typeface="Noto Sans JP"/>
-              </a:rPr>
-              <a:t>まだ特定されていない「1つ」</a:t>
+            <a:off x="3219450" y="2095500"/>
+            <a:ext cx="2314575" cy="247650"/>
+          </a:xfrm>
+          <a:prstGeom prst="rect">
+            <a:avLst/>
+          </a:prstGeom>
+          <a:noFill/>
+          <a:ln/>
+        </p:spPr>
+        <p:txBody>
+          <a:bodyPr wrap="square" lIns="0" tIns="0" rIns="0" bIns="0" anchor="ctr"/>
+          <a:lstStyle/>
+          <a:p>
+            <a:pPr/>
+            <a:r>
+              <a:rPr sz="1350" b="1">
+                <a:solidFill>
+                  <a:srgbClr val="1C2340"/>
+                </a:solidFill>
+                <a:latin typeface="Noto Sans JP"/>
+                <a:ea typeface="Noto Sans JP"/>
+              </a:rPr>
+              <a:t>特定のものではない、</a:t>
             </a:r>
           </a:p>
         </p:txBody>
@@ -3258,6 +3588,41 @@
       <p:sp>
         <p:nvSpPr>
           <p:cNvPr id="9" name=""/>
+          <p:cNvSpPr txBox="1"/>
+          <p:nvPr/>
+        </p:nvSpPr>
+        <p:spPr>
+          <a:xfrm>
+            <a:off x="3219450" y="2324100"/>
+            <a:ext cx="2238375" cy="247650"/>
+          </a:xfrm>
+          <a:prstGeom prst="rect">
+            <a:avLst/>
+          </a:prstGeom>
+          <a:noFill/>
+          <a:ln/>
+        </p:spPr>
+        <p:txBody>
+          <a:bodyPr wrap="square" lIns="0" tIns="0" rIns="0" bIns="0" anchor="ctr"/>
+          <a:lstStyle/>
+          <a:p>
+            <a:pPr/>
+            <a:r>
+              <a:rPr sz="1350" b="1">
+                <a:solidFill>
+                  <a:srgbClr val="1C2340"/>
+                </a:solidFill>
+                <a:latin typeface="Noto Sans JP"/>
+                <a:ea typeface="Noto Sans JP"/>
+              </a:rPr>
+              <a:t>一般的なもの「1つ」</a:t>
+            </a:r>
+          </a:p>
+        </p:txBody>
+      </p:sp>
+      <p:sp>
+        <p:nvSpPr>
+          <p:cNvPr id="10" name=""/>
           <p:cNvSpPr/>
           <p:nvPr/>
         </p:nvSpPr>
@@ -3279,7 +3644,7 @@
       </p:sp>
       <p:sp>
         <p:nvSpPr>
-          <p:cNvPr id="10" name=""/>
+          <p:cNvPr id="11" name=""/>
           <p:cNvSpPr txBox="1"/>
           <p:nvPr/>
         </p:nvSpPr>
@@ -3314,7 +3679,7 @@
       </p:sp>
       <p:sp>
         <p:nvSpPr>
-          <p:cNvPr id="11" name=""/>
+          <p:cNvPr id="12" name=""/>
           <p:cNvSpPr txBox="1"/>
           <p:nvPr/>
         </p:nvSpPr>
@@ -3349,7 +3714,7 @@
       </p:sp>
       <p:pic>
         <p:nvPicPr>
-          <p:cNvPr id="12" name="Image 0" descr="犬">    </p:cNvPr>
+          <p:cNvPr id="13" name="Image 0" descr="犬">    </p:cNvPr>
           <p:cNvPicPr>
             <a:picLocks noChangeAspect="1"/>
           </p:cNvPicPr>
@@ -3373,7 +3738,7 @@
       </p:pic>
       <p:sp>
         <p:nvSpPr>
-          <p:cNvPr id="13" name=""/>
+          <p:cNvPr id="14" name=""/>
           <p:cNvSpPr/>
           <p:nvPr/>
         </p:nvSpPr>
@@ -3402,7 +3767,7 @@
       </p:sp>
       <p:sp>
         <p:nvSpPr>
-          <p:cNvPr id="14" name=""/>
+          <p:cNvPr id="15" name=""/>
           <p:cNvSpPr txBox="1"/>
           <p:nvPr/>
         </p:nvSpPr>
@@ -3459,7 +3824,7 @@
       </p:sp>
       <p:sp>
         <p:nvSpPr>
-          <p:cNvPr id="15" name=""/>
+          <p:cNvPr id="16" name=""/>
           <p:cNvSpPr txBox="1"/>
           <p:nvPr/>
         </p:nvSpPr>
@@ -3494,7 +3859,7 @@
       </p:sp>
       <p:sp>
         <p:nvSpPr>
-          <p:cNvPr id="16" name=""/>
+          <p:cNvPr id="17" name=""/>
           <p:cNvSpPr/>
           <p:nvPr/>
         </p:nvSpPr>
@@ -3523,7 +3888,7 @@
       </p:sp>
       <p:sp>
         <p:nvSpPr>
-          <p:cNvPr id="17" name=""/>
+          <p:cNvPr id="18" name=""/>
           <p:cNvSpPr txBox="1"/>
           <p:nvPr/>
         </p:nvSpPr>
@@ -3569,7 +3934,7 @@
       </p:sp>
       <p:sp>
         <p:nvSpPr>
-          <p:cNvPr id="18" name=""/>
+          <p:cNvPr id="19" name=""/>
           <p:cNvSpPr txBox="1"/>
           <p:nvPr/>
         </p:nvSpPr>
@@ -3604,7 +3969,7 @@
       </p:sp>
       <p:pic>
         <p:nvPicPr>
-          <p:cNvPr id="19" name="Image 1" descr="本">    </p:cNvPr>
+          <p:cNvPr id="20" name="Image 1" descr="本">    </p:cNvPr>
           <p:cNvPicPr>
             <a:picLocks noChangeAspect="1"/>
           </p:cNvPicPr>
@@ -3628,7 +3993,7 @@
       </p:pic>
       <p:sp>
         <p:nvSpPr>
-          <p:cNvPr id="20" name=""/>
+          <p:cNvPr id="21" name=""/>
           <p:cNvSpPr/>
           <p:nvPr/>
         </p:nvSpPr>
@@ -3657,7 +4022,7 @@
       </p:sp>
       <p:sp>
         <p:nvSpPr>
-          <p:cNvPr id="21" name=""/>
+          <p:cNvPr id="22" name=""/>
           <p:cNvSpPr txBox="1"/>
           <p:nvPr/>
         </p:nvSpPr>
@@ -3714,7 +4079,7 @@
       </p:sp>
       <p:sp>
         <p:nvSpPr>
-          <p:cNvPr id="22" name=""/>
+          <p:cNvPr id="23" name=""/>
           <p:cNvSpPr txBox="1"/>
           <p:nvPr/>
         </p:nvSpPr>
@@ -3749,7 +4114,7 @@
       </p:sp>
       <p:sp>
         <p:nvSpPr>
-          <p:cNvPr id="23" name=""/>
+          <p:cNvPr id="24" name=""/>
           <p:cNvSpPr txBox="1"/>
           <p:nvPr/>
         </p:nvSpPr>
@@ -3784,7 +4149,7 @@
       </p:sp>
       <p:sp>
         <p:nvSpPr>
-          <p:cNvPr id="24" name=""/>
+          <p:cNvPr id="25" name=""/>
           <p:cNvSpPr/>
           <p:nvPr/>
         </p:nvSpPr>
@@ -3813,7 +4178,7 @@
       </p:sp>
       <p:sp>
         <p:nvSpPr>
-          <p:cNvPr id="25" name=""/>
+          <p:cNvPr id="26" name=""/>
           <p:cNvSpPr txBox="1"/>
           <p:nvPr/>
         </p:nvSpPr>
@@ -3870,7 +4235,7 @@
       </p:sp>
       <p:sp>
         <p:nvSpPr>
-          <p:cNvPr id="26" name=""/>
+          <p:cNvPr id="27" name=""/>
           <p:cNvSpPr txBox="1"/>
           <p:nvPr/>
         </p:nvSpPr>
@@ -3905,7 +4270,7 @@
       </p:sp>
       <p:sp>
         <p:nvSpPr>
-          <p:cNvPr id="27" name=""/>
+          <p:cNvPr id="28" name=""/>
           <p:cNvSpPr txBox="1"/>
           <p:nvPr/>
         </p:nvSpPr>
@@ -4225,7 +4590,7 @@
         </p:nvSpPr>
         <p:spPr>
           <a:xfrm>
-            <a:off x="3162300" y="2667000"/>
+            <a:off x="3162300" y="2457450"/>
             <a:ext cx="2457450" cy="571500"/>
           </a:xfrm>
           <a:prstGeom prst="rect">
@@ -4260,7 +4625,7 @@
         </p:nvSpPr>
         <p:spPr>
           <a:xfrm>
-            <a:off x="5153025" y="2590800"/>
+            <a:off x="5153025" y="2381250"/>
             <a:ext cx="1333500" cy="723900"/>
           </a:xfrm>
           <a:prstGeom prst="roundRect">
@@ -4287,7 +4652,7 @@
         </p:nvSpPr>
         <p:spPr>
           <a:xfrm>
-            <a:off x="6638925" y="2667000"/>
+            <a:off x="6638925" y="2457450"/>
             <a:ext cx="4114800" cy="571500"/>
           </a:xfrm>
           <a:prstGeom prst="rect">
@@ -4322,7 +4687,7 @@
         </p:nvSpPr>
         <p:spPr>
           <a:xfrm>
-            <a:off x="3162300" y="3600450"/>
+            <a:off x="3162300" y="3314700"/>
             <a:ext cx="1333500" cy="723900"/>
           </a:xfrm>
           <a:prstGeom prst="roundRect">
@@ -4349,7 +4714,7 @@
         </p:nvSpPr>
         <p:spPr>
           <a:xfrm>
-            <a:off x="4648200" y="3676650"/>
+            <a:off x="4648200" y="3390900"/>
             <a:ext cx="5248275" cy="571500"/>
           </a:xfrm>
           <a:prstGeom prst="rect">
@@ -4379,6 +4744,41 @@
       <p:sp>
         <p:nvSpPr>
           <p:cNvPr id="13" name=""/>
+          <p:cNvSpPr txBox="1"/>
+          <p:nvPr/>
+        </p:nvSpPr>
+        <p:spPr>
+          <a:xfrm>
+            <a:off x="3162300" y="4229100"/>
+            <a:ext cx="8867775" cy="352425"/>
+          </a:xfrm>
+          <a:prstGeom prst="rect">
+            <a:avLst/>
+          </a:prstGeom>
+          <a:noFill/>
+          <a:ln/>
+        </p:spPr>
+        <p:txBody>
+          <a:bodyPr wrap="square" lIns="0" tIns="0" rIns="0" bIns="0" anchor="ctr"/>
+          <a:lstStyle/>
+          <a:p>
+            <a:pPr/>
+            <a:r>
+              <a:rPr sz="1950" b="1">
+                <a:solidFill>
+                  <a:srgbClr val="4A5270"/>
+                </a:solidFill>
+                <a:latin typeface="Noto Sans JP"/>
+                <a:ea typeface="Noto Sans JP"/>
+              </a:rPr>
+              <a:t>昨日、あるカフェに行きました。そのカフェはとても静かでした。</a:t>
+            </a:r>
+          </a:p>
+        </p:txBody>
+      </p:sp>
+      <p:sp>
+        <p:nvSpPr>
+          <p:cNvPr id="14" name=""/>
           <p:cNvSpPr/>
           <p:nvPr/>
         </p:nvSpPr>
@@ -4400,7 +4800,7 @@
       </p:sp>
       <p:sp>
         <p:nvSpPr>
-          <p:cNvPr id="14" name=""/>
+          <p:cNvPr id="15" name=""/>
           <p:cNvSpPr txBox="1"/>
           <p:nvPr/>
         </p:nvSpPr>
@@ -4435,7 +4835,7 @@
       </p:sp>
       <p:sp>
         <p:nvSpPr>
-          <p:cNvPr id="15" name=""/>
+          <p:cNvPr id="16" name=""/>
           <p:cNvSpPr txBox="1"/>
           <p:nvPr/>
         </p:nvSpPr>
@@ -4470,7 +4870,7 @@
       </p:sp>
       <p:sp>
         <p:nvSpPr>
-          <p:cNvPr id="16" name=""/>
+          <p:cNvPr id="17" name=""/>
           <p:cNvSpPr/>
           <p:nvPr/>
         </p:nvSpPr>
@@ -4492,7 +4892,7 @@
       </p:sp>
       <p:sp>
         <p:nvSpPr>
-          <p:cNvPr id="17" name=""/>
+          <p:cNvPr id="18" name=""/>
           <p:cNvSpPr txBox="1"/>
           <p:nvPr/>
         </p:nvSpPr>
@@ -4527,7 +4927,7 @@
       </p:sp>
       <p:sp>
         <p:nvSpPr>
-          <p:cNvPr id="18" name=""/>
+          <p:cNvPr id="19" name=""/>
           <p:cNvSpPr txBox="1"/>
           <p:nvPr/>
         </p:nvSpPr>
@@ -4847,7 +5247,7 @@
         </p:nvSpPr>
         <p:spPr>
           <a:xfrm>
-            <a:off x="3162300" y="2667000"/>
+            <a:off x="3162300" y="2457450"/>
             <a:ext cx="2457450" cy="571500"/>
           </a:xfrm>
           <a:prstGeom prst="rect">
@@ -4882,7 +5282,7 @@
         </p:nvSpPr>
         <p:spPr>
           <a:xfrm>
-            <a:off x="5153025" y="2590800"/>
+            <a:off x="5153025" y="2381250"/>
             <a:ext cx="1333500" cy="723900"/>
           </a:xfrm>
           <a:prstGeom prst="roundRect">
@@ -4904,7 +5304,7 @@
         </p:nvSpPr>
         <p:spPr>
           <a:xfrm>
-            <a:off x="5505450" y="2676525"/>
+            <a:off x="5505450" y="2466975"/>
             <a:ext cx="628650" cy="552450"/>
           </a:xfrm>
           <a:prstGeom prst="rect">
@@ -4939,7 +5339,7 @@
         </p:nvSpPr>
         <p:spPr>
           <a:xfrm>
-            <a:off x="6638925" y="2667000"/>
+            <a:off x="6638925" y="2457450"/>
             <a:ext cx="4114800" cy="571500"/>
           </a:xfrm>
           <a:prstGeom prst="rect">
@@ -4974,7 +5374,7 @@
         </p:nvSpPr>
         <p:spPr>
           <a:xfrm>
-            <a:off x="3162300" y="3600450"/>
+            <a:off x="3162300" y="3314700"/>
             <a:ext cx="1333500" cy="723900"/>
           </a:xfrm>
           <a:prstGeom prst="roundRect">
@@ -4996,7 +5396,7 @@
         </p:nvSpPr>
         <p:spPr>
           <a:xfrm>
-            <a:off x="3219450" y="3686175"/>
+            <a:off x="3219450" y="3400425"/>
             <a:ext cx="1219200" cy="552450"/>
           </a:xfrm>
           <a:prstGeom prst="rect">
@@ -5031,7 +5431,7 @@
         </p:nvSpPr>
         <p:spPr>
           <a:xfrm>
-            <a:off x="4648200" y="3676650"/>
+            <a:off x="4648200" y="3390900"/>
             <a:ext cx="5248275" cy="571500"/>
           </a:xfrm>
           <a:prstGeom prst="rect">
@@ -5061,6 +5461,41 @@
       <p:sp>
         <p:nvSpPr>
           <p:cNvPr id="15" name=""/>
+          <p:cNvSpPr txBox="1"/>
+          <p:nvPr/>
+        </p:nvSpPr>
+        <p:spPr>
+          <a:xfrm>
+            <a:off x="3162300" y="4229100"/>
+            <a:ext cx="8867775" cy="352425"/>
+          </a:xfrm>
+          <a:prstGeom prst="rect">
+            <a:avLst/>
+          </a:prstGeom>
+          <a:noFill/>
+          <a:ln/>
+        </p:spPr>
+        <p:txBody>
+          <a:bodyPr wrap="square" lIns="0" tIns="0" rIns="0" bIns="0" anchor="ctr"/>
+          <a:lstStyle/>
+          <a:p>
+            <a:pPr/>
+            <a:r>
+              <a:rPr sz="1950" b="1">
+                <a:solidFill>
+                  <a:srgbClr val="4A5270"/>
+                </a:solidFill>
+                <a:latin typeface="Noto Sans JP"/>
+                <a:ea typeface="Noto Sans JP"/>
+              </a:rPr>
+              <a:t>昨日、あるカフェに行きました。そのカフェはとても静かでした。</a:t>
+            </a:r>
+          </a:p>
+        </p:txBody>
+      </p:sp>
+      <p:sp>
+        <p:nvSpPr>
+          <p:cNvPr id="16" name=""/>
           <p:cNvSpPr/>
           <p:nvPr/>
         </p:nvSpPr>
@@ -5089,13 +5524,13 @@
       </p:sp>
       <p:sp>
         <p:nvSpPr>
-          <p:cNvPr id="16" name=""/>
+          <p:cNvPr id="17" name=""/>
           <p:cNvSpPr/>
           <p:nvPr/>
         </p:nvSpPr>
         <p:spPr>
           <a:xfrm>
-            <a:off x="990600" y="5210175"/>
+            <a:off x="990600" y="5391150"/>
             <a:ext cx="790575" cy="371475"/>
           </a:xfrm>
           <a:prstGeom prst="roundRect">
@@ -5111,13 +5546,13 @@
       </p:sp>
       <p:sp>
         <p:nvSpPr>
-          <p:cNvPr id="17" name=""/>
-          <p:cNvSpPr txBox="1"/>
-          <p:nvPr/>
-        </p:nvSpPr>
-        <p:spPr>
-          <a:xfrm>
-            <a:off x="1162050" y="5267325"/>
+          <p:cNvPr id="18" name=""/>
+          <p:cNvSpPr txBox="1"/>
+          <p:nvPr/>
+        </p:nvSpPr>
+        <p:spPr>
+          <a:xfrm>
+            <a:off x="1162050" y="5448300"/>
             <a:ext cx="857250" cy="247650"/>
           </a:xfrm>
           <a:prstGeom prst="rect">
@@ -5146,13 +5581,13 @@
       </p:sp>
       <p:sp>
         <p:nvSpPr>
-          <p:cNvPr id="18" name=""/>
-          <p:cNvSpPr txBox="1"/>
-          <p:nvPr/>
-        </p:nvSpPr>
-        <p:spPr>
-          <a:xfrm>
-            <a:off x="1914525" y="5229225"/>
+          <p:cNvPr id="19" name=""/>
+          <p:cNvSpPr txBox="1"/>
+          <p:nvPr/>
+        </p:nvSpPr>
+        <p:spPr>
+          <a:xfrm>
+            <a:off x="1914525" y="5410200"/>
             <a:ext cx="3086100" cy="333375"/>
           </a:xfrm>
           <a:prstGeom prst="rect">
@@ -5214,13 +5649,13 @@
       </p:sp>
       <p:sp>
         <p:nvSpPr>
-          <p:cNvPr id="19" name=""/>
+          <p:cNvPr id="20" name=""/>
           <p:cNvSpPr/>
           <p:nvPr/>
         </p:nvSpPr>
         <p:spPr>
           <a:xfrm>
-            <a:off x="990600" y="5676900"/>
+            <a:off x="990600" y="5857875"/>
             <a:ext cx="790575" cy="371475"/>
           </a:xfrm>
           <a:prstGeom prst="roundRect">
@@ -5236,13 +5671,13 @@
       </p:sp>
       <p:sp>
         <p:nvSpPr>
-          <p:cNvPr id="20" name=""/>
-          <p:cNvSpPr txBox="1"/>
-          <p:nvPr/>
-        </p:nvSpPr>
-        <p:spPr>
-          <a:xfrm>
-            <a:off x="1162050" y="5734050"/>
+          <p:cNvPr id="21" name=""/>
+          <p:cNvSpPr txBox="1"/>
+          <p:nvPr/>
+        </p:nvSpPr>
+        <p:spPr>
+          <a:xfrm>
+            <a:off x="1162050" y="5915025"/>
             <a:ext cx="857250" cy="247650"/>
           </a:xfrm>
           <a:prstGeom prst="rect">
@@ -5271,13 +5706,13 @@
       </p:sp>
       <p:sp>
         <p:nvSpPr>
-          <p:cNvPr id="21" name=""/>
-          <p:cNvSpPr txBox="1"/>
-          <p:nvPr/>
-        </p:nvSpPr>
-        <p:spPr>
-          <a:xfrm>
-            <a:off x="1914525" y="5695950"/>
+          <p:cNvPr id="22" name=""/>
+          <p:cNvSpPr txBox="1"/>
+          <p:nvPr/>
+        </p:nvSpPr>
+        <p:spPr>
+          <a:xfrm>
+            <a:off x="1914525" y="5876925"/>
             <a:ext cx="5734050" cy="333375"/>
           </a:xfrm>
           <a:prstGeom prst="rect">
@@ -5333,41 +5768,6 @@
                 <a:ea typeface="DM Sans"/>
               </a:rPr>
               <a:t>cafe</a:t>
-            </a:r>
-          </a:p>
-        </p:txBody>
-      </p:sp>
-      <p:sp>
-        <p:nvSpPr>
-          <p:cNvPr id="22" name=""/>
-          <p:cNvSpPr txBox="1"/>
-          <p:nvPr/>
-        </p:nvSpPr>
-        <p:spPr>
-          <a:xfrm>
-            <a:off x="990600" y="6162675"/>
-            <a:ext cx="6562725" cy="257175"/>
-          </a:xfrm>
-          <a:prstGeom prst="rect">
-            <a:avLst/>
-          </a:prstGeom>
-          <a:noFill/>
-          <a:ln/>
-        </p:spPr>
-        <p:txBody>
-          <a:bodyPr wrap="square" lIns="0" tIns="0" rIns="0" bIns="0" anchor="ctr"/>
-          <a:lstStyle/>
-          <a:p>
-            <a:pPr/>
-            <a:r>
-              <a:rPr sz="1450">
-                <a:solidFill>
-                  <a:srgbClr val="4A5270"/>
-                </a:solidFill>
-                <a:latin typeface="Noto Sans JP"/>
-                <a:ea typeface="Noto Sans JP"/>
-              </a:rPr>
-              <a:t>昨日、あるカフェに行きました。そのカフェはとても静かでした。</a:t>
             </a:r>
           </a:p>
         </p:txBody>
@@ -10473,11 +10873,11 @@
         <p:spPr>
           <a:xfrm>
             <a:off x="685800" y="2028825"/>
-            <a:ext cx="5305425" cy="1638300"/>
+            <a:ext cx="5305425" cy="1590675"/>
           </a:xfrm>
           <a:prstGeom prst="roundRect">
             <a:avLst>
-              <a:gd name="adj" fmla="val 15116"/>
+              <a:gd name="adj" fmla="val 15569"/>
             </a:avLst>
           </a:prstGeom>
           <a:solidFill>
@@ -10502,7 +10902,7 @@
         </p:blipFill>
         <p:spPr>
           <a:xfrm>
-            <a:off x="895350" y="2200275"/>
+            <a:off x="895350" y="2181225"/>
             <a:ext cx="1295400" cy="1295400"/>
           </a:xfrm>
           <a:prstGeom prst="rect">
@@ -10518,7 +10918,7 @@
         </p:nvSpPr>
         <p:spPr>
           <a:xfrm>
-            <a:off x="2400300" y="2476500"/>
+            <a:off x="2400300" y="2457450"/>
             <a:ext cx="2743200" cy="390525"/>
           </a:xfrm>
           <a:prstGeom prst="rect">
@@ -10575,7 +10975,7 @@
         </p:nvSpPr>
         <p:spPr>
           <a:xfrm>
-            <a:off x="2400300" y="2943225"/>
+            <a:off x="2400300" y="2924175"/>
             <a:ext cx="3171825" cy="257175"/>
           </a:xfrm>
           <a:prstGeom prst="rect">
@@ -10611,11 +11011,11 @@
         <p:spPr>
           <a:xfrm>
             <a:off x="6200775" y="2028825"/>
-            <a:ext cx="5305425" cy="1638300"/>
+            <a:ext cx="5305425" cy="1590675"/>
           </a:xfrm>
           <a:prstGeom prst="roundRect">
             <a:avLst>
-              <a:gd name="adj" fmla="val 15116"/>
+              <a:gd name="adj" fmla="val 15569"/>
             </a:avLst>
           </a:prstGeom>
           <a:solidFill>
@@ -10640,7 +11040,7 @@
         </p:blipFill>
         <p:spPr>
           <a:xfrm>
-            <a:off x="6410325" y="2200275"/>
+            <a:off x="6410325" y="2181225"/>
             <a:ext cx="1295400" cy="1295400"/>
           </a:xfrm>
           <a:prstGeom prst="rect">
@@ -10656,7 +11056,7 @@
         </p:nvSpPr>
         <p:spPr>
           <a:xfrm>
-            <a:off x="7915275" y="2295525"/>
+            <a:off x="7915275" y="2266950"/>
             <a:ext cx="2114550" cy="390525"/>
           </a:xfrm>
           <a:prstGeom prst="rect">
@@ -10713,7 +11113,7 @@
         </p:nvSpPr>
         <p:spPr>
           <a:xfrm>
-            <a:off x="7915275" y="2667000"/>
+            <a:off x="7915275" y="2638425"/>
             <a:ext cx="2181225" cy="390525"/>
           </a:xfrm>
           <a:prstGeom prst="rect">
@@ -10748,7 +11148,7 @@
         </p:nvSpPr>
         <p:spPr>
           <a:xfrm>
-            <a:off x="7915275" y="3124200"/>
+            <a:off x="7915275" y="3105150"/>
             <a:ext cx="3171825" cy="257175"/>
           </a:xfrm>
           <a:prstGeom prst="rect">
@@ -10783,12 +11183,12 @@
         </p:nvSpPr>
         <p:spPr>
           <a:xfrm>
-            <a:off x="685800" y="3876675"/>
-            <a:ext cx="5305425" cy="1638300"/>
+            <a:off x="685800" y="3829050"/>
+            <a:ext cx="5305425" cy="1590675"/>
           </a:xfrm>
           <a:prstGeom prst="roundRect">
             <a:avLst>
-              <a:gd name="adj" fmla="val 15116"/>
+              <a:gd name="adj" fmla="val 15569"/>
             </a:avLst>
           </a:prstGeom>
           <a:solidFill>
@@ -10813,7 +11213,7 @@
         </p:blipFill>
         <p:spPr>
           <a:xfrm>
-            <a:off x="895350" y="4048125"/>
+            <a:off x="895350" y="3981450"/>
             <a:ext cx="1295400" cy="1295400"/>
           </a:xfrm>
           <a:prstGeom prst="rect">
@@ -10829,7 +11229,7 @@
         </p:nvSpPr>
         <p:spPr>
           <a:xfrm>
-            <a:off x="2400300" y="4324350"/>
+            <a:off x="2400300" y="4257675"/>
             <a:ext cx="3038475" cy="390525"/>
           </a:xfrm>
           <a:prstGeom prst="rect">
@@ -10886,7 +11286,7 @@
         </p:nvSpPr>
         <p:spPr>
           <a:xfrm>
-            <a:off x="2400300" y="4791075"/>
+            <a:off x="2400300" y="4714875"/>
             <a:ext cx="1990725" cy="257175"/>
           </a:xfrm>
           <a:prstGeom prst="rect">
@@ -10921,12 +11321,12 @@
         </p:nvSpPr>
         <p:spPr>
           <a:xfrm>
-            <a:off x="6200775" y="3876675"/>
-            <a:ext cx="5305425" cy="1638300"/>
+            <a:off x="6200775" y="3829050"/>
+            <a:ext cx="5305425" cy="1590675"/>
           </a:xfrm>
           <a:prstGeom prst="roundRect">
             <a:avLst>
-              <a:gd name="adj" fmla="val 15116"/>
+              <a:gd name="adj" fmla="val 15569"/>
             </a:avLst>
           </a:prstGeom>
           <a:solidFill>
@@ -10951,7 +11351,7 @@
         </p:blipFill>
         <p:spPr>
           <a:xfrm>
-            <a:off x="6410325" y="4048125"/>
+            <a:off x="6410325" y="3981450"/>
             <a:ext cx="1295400" cy="1295400"/>
           </a:xfrm>
           <a:prstGeom prst="rect">
@@ -10967,7 +11367,7 @@
         </p:nvSpPr>
         <p:spPr>
           <a:xfrm>
-            <a:off x="7915275" y="4324350"/>
+            <a:off x="7915275" y="4257675"/>
             <a:ext cx="2628900" cy="390525"/>
           </a:xfrm>
           <a:prstGeom prst="rect">
@@ -11024,7 +11424,7 @@
         </p:nvSpPr>
         <p:spPr>
           <a:xfrm>
-            <a:off x="7915275" y="4791075"/>
+            <a:off x="7915275" y="4714875"/>
             <a:ext cx="3171825" cy="257175"/>
           </a:xfrm>
           <a:prstGeom prst="rect">
@@ -11059,12 +11459,12 @@
         </p:nvSpPr>
         <p:spPr>
           <a:xfrm>
-            <a:off x="685800" y="5724525"/>
-            <a:ext cx="10820400" cy="714375"/>
+            <a:off x="685800" y="5629275"/>
+            <a:ext cx="10820400" cy="809625"/>
           </a:xfrm>
           <a:prstGeom prst="roundRect">
             <a:avLst>
-              <a:gd name="adj" fmla="val 26667"/>
+              <a:gd name="adj" fmla="val 23529"/>
             </a:avLst>
           </a:prstGeom>
           <a:solidFill>
@@ -11088,7 +11488,7 @@
         </p:nvSpPr>
         <p:spPr>
           <a:xfrm>
-            <a:off x="933450" y="5895975"/>
+            <a:off x="933450" y="5848350"/>
             <a:ext cx="1371600" cy="371475"/>
           </a:xfrm>
           <a:prstGeom prst="roundRect">
@@ -11110,7 +11510,7 @@
         </p:nvSpPr>
         <p:spPr>
           <a:xfrm>
-            <a:off x="1104900" y="5953125"/>
+            <a:off x="1104900" y="5905500"/>
             <a:ext cx="1524000" cy="247650"/>
           </a:xfrm>
           <a:prstGeom prst="rect">
@@ -11140,35 +11540,79 @@
       <p:sp>
         <p:nvSpPr>
           <p:cNvPr id="26" name=""/>
-          <p:cNvSpPr txBox="1"/>
-          <p:nvPr/>
-        </p:nvSpPr>
-        <p:spPr>
-          <a:xfrm>
-            <a:off x="2457450" y="5934075"/>
-            <a:ext cx="8524875" cy="304800"/>
-          </a:xfrm>
-          <a:prstGeom prst="rect">
-            <a:avLst/>
-          </a:prstGeom>
-          <a:noFill/>
-          <a:ln/>
-        </p:spPr>
-        <p:txBody>
-          <a:bodyPr wrap="square" lIns="0" tIns="0" rIns="0" bIns="0" anchor="ctr"/>
-          <a:lstStyle/>
-          <a:p>
-            <a:pPr/>
-            <a:r>
-              <a:rPr sz="1650">
-                <a:solidFill>
-                  <a:srgbClr val="1C2340"/>
-                </a:solidFill>
-                <a:latin typeface="Noto Sans JP"/>
-                <a:ea typeface="Noto Sans JP"/>
-              </a:rPr>
-              <a:t>まだ相手が「どれのことか」分かっていないものを、</a:t>
-            </a:r>
+          <p:cNvSpPr/>
+          <p:nvPr/>
+        </p:nvSpPr>
+        <p:spPr>
+          <a:xfrm>
+            <a:off x="2571750" y="5886450"/>
+            <a:ext cx="304800" cy="304800"/>
+          </a:xfrm>
+          <a:prstGeom prst="ellipse">
+            <a:avLst/>
+          </a:prstGeom>
+          <a:solidFill>
+            <a:srgbClr val="E8461E"/>
+          </a:solidFill>
+          <a:ln/>
+        </p:spPr>
+      </p:sp>
+      <p:sp>
+        <p:nvSpPr>
+          <p:cNvPr id="27" name=""/>
+          <p:cNvSpPr txBox="1"/>
+          <p:nvPr/>
+        </p:nvSpPr>
+        <p:spPr>
+          <a:xfrm>
+            <a:off x="2524125" y="5934075"/>
+            <a:ext cx="409575" cy="209550"/>
+          </a:xfrm>
+          <a:prstGeom prst="rect">
+            <a:avLst/>
+          </a:prstGeom>
+          <a:noFill/>
+          <a:ln/>
+        </p:spPr>
+        <p:txBody>
+          <a:bodyPr wrap="square" lIns="0" tIns="0" rIns="0" bIns="0" anchor="ctr"/>
+          <a:lstStyle/>
+          <a:p>
+            <a:pPr algn="ctr"/>
+            <a:r>
+              <a:rPr sz="1300" b="1">
+                <a:solidFill>
+                  <a:srgbClr val="FFFFFF"/>
+                </a:solidFill>
+                <a:latin typeface="DM Sans"/>
+                <a:ea typeface="DM Sans"/>
+              </a:rPr>
+              <a:t>1</a:t>
+            </a:r>
+          </a:p>
+        </p:txBody>
+      </p:sp>
+      <p:sp>
+        <p:nvSpPr>
+          <p:cNvPr id="28" name=""/>
+          <p:cNvSpPr txBox="1"/>
+          <p:nvPr/>
+        </p:nvSpPr>
+        <p:spPr>
+          <a:xfrm>
+            <a:off x="2990850" y="5886450"/>
+            <a:ext cx="1933575" cy="304800"/>
+          </a:xfrm>
+          <a:prstGeom prst="rect">
+            <a:avLst/>
+          </a:prstGeom>
+          <a:noFill/>
+          <a:ln/>
+        </p:spPr>
+        <p:txBody>
+          <a:bodyPr wrap="square" lIns="0" tIns="0" rIns="0" bIns="0" anchor="ctr"/>
+          <a:lstStyle/>
+          <a:p>
             <a:pPr/>
             <a:r>
               <a:rPr sz="1650" b="1">
@@ -11178,18 +11622,132 @@
                 <a:latin typeface="Noto Sans JP"/>
                 <a:ea typeface="Noto Sans JP"/>
               </a:rPr>
-              <a:t>初めて会話に出す</a:t>
-            </a:r>
-            <a:pPr/>
-            <a:r>
-              <a:rPr sz="1650">
-                <a:solidFill>
-                  <a:srgbClr val="1C2340"/>
-                </a:solidFill>
-                <a:latin typeface="Noto Sans JP"/>
-                <a:ea typeface="Noto Sans JP"/>
-              </a:rPr>
-              <a:t>とき</a:t>
+              <a:t>「1つ」のとき</a:t>
+            </a:r>
+          </a:p>
+        </p:txBody>
+      </p:sp>
+      <p:sp>
+        <p:nvSpPr>
+          <p:cNvPr id="29" name=""/>
+          <p:cNvSpPr/>
+          <p:nvPr/>
+        </p:nvSpPr>
+        <p:spPr>
+          <a:xfrm>
+            <a:off x="4638675" y="5886450"/>
+            <a:ext cx="304800" cy="304800"/>
+          </a:xfrm>
+          <a:prstGeom prst="ellipse">
+            <a:avLst/>
+          </a:prstGeom>
+          <a:solidFill>
+            <a:srgbClr val="E8461E"/>
+          </a:solidFill>
+          <a:ln/>
+        </p:spPr>
+      </p:sp>
+      <p:sp>
+        <p:nvSpPr>
+          <p:cNvPr id="30" name=""/>
+          <p:cNvSpPr txBox="1"/>
+          <p:nvPr/>
+        </p:nvSpPr>
+        <p:spPr>
+          <a:xfrm>
+            <a:off x="4562475" y="5934075"/>
+            <a:ext cx="457200" cy="209550"/>
+          </a:xfrm>
+          <a:prstGeom prst="rect">
+            <a:avLst/>
+          </a:prstGeom>
+          <a:noFill/>
+          <a:ln/>
+        </p:spPr>
+        <p:txBody>
+          <a:bodyPr wrap="square" lIns="0" tIns="0" rIns="0" bIns="0" anchor="ctr"/>
+          <a:lstStyle/>
+          <a:p>
+            <a:pPr algn="ctr"/>
+            <a:r>
+              <a:rPr sz="1300" b="1">
+                <a:solidFill>
+                  <a:srgbClr val="FFFFFF"/>
+                </a:solidFill>
+                <a:latin typeface="DM Sans"/>
+                <a:ea typeface="DM Sans"/>
+              </a:rPr>
+              <a:t>2</a:t>
+            </a:r>
+          </a:p>
+        </p:txBody>
+      </p:sp>
+      <p:sp>
+        <p:nvSpPr>
+          <p:cNvPr id="31" name=""/>
+          <p:cNvSpPr txBox="1"/>
+          <p:nvPr/>
+        </p:nvSpPr>
+        <p:spPr>
+          <a:xfrm>
+            <a:off x="5057775" y="5762625"/>
+            <a:ext cx="3705225" cy="304800"/>
+          </a:xfrm>
+          <a:prstGeom prst="rect">
+            <a:avLst/>
+          </a:prstGeom>
+          <a:noFill/>
+          <a:ln/>
+        </p:spPr>
+        <p:txBody>
+          <a:bodyPr wrap="square" lIns="0" tIns="0" rIns="0" bIns="0" anchor="ctr"/>
+          <a:lstStyle/>
+          <a:p>
+            <a:pPr/>
+            <a:r>
+              <a:rPr sz="1650" b="1">
+                <a:solidFill>
+                  <a:srgbClr val="1C2340"/>
+                </a:solidFill>
+                <a:latin typeface="Noto Sans JP"/>
+                <a:ea typeface="Noto Sans JP"/>
+              </a:rPr>
+              <a:t>一般的なものを指しているとき</a:t>
+            </a:r>
+          </a:p>
+        </p:txBody>
+      </p:sp>
+      <p:sp>
+        <p:nvSpPr>
+          <p:cNvPr id="32" name=""/>
+          <p:cNvSpPr txBox="1"/>
+          <p:nvPr/>
+        </p:nvSpPr>
+        <p:spPr>
+          <a:xfrm>
+            <a:off x="5057775" y="6067425"/>
+            <a:ext cx="3867150" cy="238125"/>
+          </a:xfrm>
+          <a:prstGeom prst="rect">
+            <a:avLst/>
+          </a:prstGeom>
+          <a:noFill/>
+          <a:ln/>
+        </p:spPr>
+        <p:txBody>
+          <a:bodyPr wrap="square" lIns="0" tIns="0" rIns="0" bIns="0" anchor="ctr"/>
+          <a:lstStyle/>
+          <a:p>
+            <a:pPr/>
+            <a:r>
+              <a:rPr sz="1300">
+                <a:solidFill>
+                  <a:srgbClr val="4A5270"/>
+                </a:solidFill>
+                <a:latin typeface="Noto Sans JP"/>
+                <a:ea typeface="Noto Sans JP"/>
+              </a:rPr>
+              <a:t>（特定のものを話しているわけではない）</a:t>
             </a:r>
           </a:p>
         </p:txBody>
@@ -12310,7 +12868,7 @@
       </p:sp>
       <p:pic>
         <p:nvPicPr>
-          <p:cNvPr id="21" name="Image 2" descr="大学">    </p:cNvPr>
+          <p:cNvPr id="21" name="Image 2" descr="えんぴつ">    </p:cNvPr>
           <p:cNvPicPr>
             <a:picLocks noChangeAspect="1"/>
           </p:cNvPicPr>
@@ -12341,7 +12899,7 @@
         <p:spPr>
           <a:xfrm>
             <a:off x="2133600" y="5534025"/>
-            <a:ext cx="2343150" cy="400050"/>
+            <a:ext cx="1676400" cy="400050"/>
           </a:xfrm>
           <a:prstGeom prst="rect">
             <a:avLst/>
@@ -12373,7 +12931,7 @@
                 <a:latin typeface="DM Sans"/>
                 <a:ea typeface="DM Sans"/>
               </a:rPr>
-              <a:t> university</a:t>
+              <a:t> pencil</a:t>
             </a:r>
           </a:p>
         </p:txBody>
@@ -13280,12 +13838,12 @@
         </p:nvSpPr>
         <p:spPr>
           <a:xfrm>
-            <a:off x="1009650" y="5238750"/>
-            <a:ext cx="4638675" cy="952500"/>
+            <a:off x="1009650" y="5543550"/>
+            <a:ext cx="2657475" cy="647700"/>
           </a:xfrm>
           <a:prstGeom prst="roundRect">
             <a:avLst>
-              <a:gd name="adj" fmla="val 18000"/>
+              <a:gd name="adj" fmla="val 23529"/>
             </a:avLst>
           </a:prstGeom>
           <a:solidFill>
@@ -13302,33 +13860,22 @@
         </p:nvSpPr>
         <p:spPr>
           <a:xfrm>
-            <a:off x="1238250" y="5391150"/>
-            <a:ext cx="4400550" cy="352425"/>
-          </a:xfrm>
-          <a:prstGeom prst="rect">
-            <a:avLst/>
-          </a:prstGeom>
-          <a:noFill/>
-          <a:ln/>
-        </p:spPr>
-        <p:txBody>
-          <a:bodyPr wrap="square" lIns="0" tIns="0" rIns="0" bIns="0" anchor="ctr"/>
-          <a:lstStyle/>
-          <a:p>
-            <a:pPr/>
-            <a:r>
-              <a:rPr sz="2100" b="1">
-                <a:solidFill>
-                  <a:srgbClr val="1C2340"/>
-                </a:solidFill>
-                <a:latin typeface="DM Sans"/>
-                <a:ea typeface="DM Sans"/>
-              </a:rPr>
-              <a:t>She is </a:t>
-            </a:r>
-            <a:pPr/>
-            <a:r>
-              <a:rPr sz="2100" b="1">
+            <a:off x="1257300" y="5619750"/>
+            <a:ext cx="2828925" cy="495300"/>
+          </a:xfrm>
+          <a:prstGeom prst="rect">
+            <a:avLst/>
+          </a:prstGeom>
+          <a:noFill/>
+          <a:ln/>
+        </p:spPr>
+        <p:txBody>
+          <a:bodyPr wrap="square" lIns="0" tIns="0" rIns="0" bIns="0" anchor="ctr"/>
+          <a:lstStyle/>
+          <a:p>
+            <a:pPr/>
+            <a:r>
+              <a:rPr sz="3000" b="1">
                 <a:solidFill>
                   <a:srgbClr val="E8461E"/>
                 </a:solidFill>
@@ -13339,14 +13886,14 @@
             </a:r>
             <a:pPr/>
             <a:r>
-              <a:rPr sz="2100" b="1">
-                <a:solidFill>
-                  <a:srgbClr val="1C2340"/>
-                </a:solidFill>
-                <a:latin typeface="DM Sans"/>
-                <a:ea typeface="DM Sans"/>
-              </a:rPr>
-              <a:t> university student.</a:t>
+              <a:rPr sz="3000" b="1">
+                <a:solidFill>
+                  <a:srgbClr val="1C2340"/>
+                </a:solidFill>
+                <a:latin typeface="DM Sans"/>
+                <a:ea typeface="DM Sans"/>
+              </a:rPr>
+              <a:t> university</a:t>
             </a:r>
           </a:p>
         </p:txBody>
@@ -13354,41 +13901,6 @@
       <p:sp>
         <p:nvSpPr>
           <p:cNvPr id="15" name=""/>
-          <p:cNvSpPr txBox="1"/>
-          <p:nvPr/>
-        </p:nvSpPr>
-        <p:spPr>
-          <a:xfrm>
-            <a:off x="1238250" y="5781675"/>
-            <a:ext cx="2190750" cy="257175"/>
-          </a:xfrm>
-          <a:prstGeom prst="rect">
-            <a:avLst/>
-          </a:prstGeom>
-          <a:noFill/>
-          <a:ln/>
-        </p:spPr>
-        <p:txBody>
-          <a:bodyPr wrap="square" lIns="0" tIns="0" rIns="0" bIns="0" anchor="ctr"/>
-          <a:lstStyle/>
-          <a:p>
-            <a:pPr/>
-            <a:r>
-              <a:rPr sz="1450">
-                <a:solidFill>
-                  <a:srgbClr val="4A5270"/>
-                </a:solidFill>
-                <a:latin typeface="Noto Sans JP"/>
-                <a:ea typeface="Noto Sans JP"/>
-              </a:rPr>
-              <a:t>彼女は大学生です。</a:t>
-            </a:r>
-          </a:p>
-        </p:txBody>
-      </p:sp>
-      <p:sp>
-        <p:nvSpPr>
-          <p:cNvPr id="16" name=""/>
           <p:cNvSpPr/>
           <p:nvPr/>
         </p:nvSpPr>
@@ -13417,7 +13929,7 @@
       </p:sp>
       <p:pic>
         <p:nvPicPr>
-          <p:cNvPr id="17" name="Image 1" descr="時計">    </p:cNvPr>
+          <p:cNvPr id="16" name="Image 1" descr="時計">    </p:cNvPr>
           <p:cNvPicPr>
             <a:picLocks noChangeAspect="1"/>
           </p:cNvPicPr>
@@ -13441,7 +13953,7 @@
       </p:pic>
       <p:sp>
         <p:nvSpPr>
-          <p:cNvPr id="18" name=""/>
+          <p:cNvPr id="17" name=""/>
           <p:cNvSpPr txBox="1"/>
           <p:nvPr/>
         </p:nvSpPr>
@@ -13487,7 +13999,7 @@
       </p:sp>
       <p:sp>
         <p:nvSpPr>
-          <p:cNvPr id="19" name=""/>
+          <p:cNvPr id="18" name=""/>
           <p:cNvSpPr txBox="1"/>
           <p:nvPr/>
         </p:nvSpPr>
@@ -13544,7 +14056,7 @@
       </p:sp>
       <p:sp>
         <p:nvSpPr>
-          <p:cNvPr id="20" name=""/>
+          <p:cNvPr id="19" name=""/>
           <p:cNvSpPr/>
           <p:nvPr/>
         </p:nvSpPr>
@@ -13567,7 +14079,7 @@
       </p:sp>
       <p:sp>
         <p:nvSpPr>
-          <p:cNvPr id="21" name=""/>
+          <p:cNvPr id="20" name=""/>
           <p:cNvSpPr txBox="1"/>
           <p:nvPr/>
         </p:nvSpPr>
@@ -13635,7 +14147,7 @@
       </p:sp>
       <p:sp>
         <p:nvSpPr>
-          <p:cNvPr id="22" name=""/>
+          <p:cNvPr id="21" name=""/>
           <p:cNvSpPr txBox="1"/>
           <p:nvPr/>
         </p:nvSpPr>
@@ -13670,18 +14182,18 @@
       </p:sp>
       <p:sp>
         <p:nvSpPr>
-          <p:cNvPr id="23" name=""/>
+          <p:cNvPr id="22" name=""/>
           <p:cNvSpPr/>
           <p:nvPr/>
         </p:nvSpPr>
         <p:spPr>
           <a:xfrm>
-            <a:off x="6543675" y="5238750"/>
-            <a:ext cx="4638675" cy="952500"/>
+            <a:off x="6543675" y="5543550"/>
+            <a:ext cx="1895475" cy="647700"/>
           </a:xfrm>
           <a:prstGeom prst="roundRect">
             <a:avLst>
-              <a:gd name="adj" fmla="val 18000"/>
+              <a:gd name="adj" fmla="val 23529"/>
             </a:avLst>
           </a:prstGeom>
           <a:solidFill>
@@ -13692,39 +14204,28 @@
       </p:sp>
       <p:sp>
         <p:nvSpPr>
-          <p:cNvPr id="24" name=""/>
-          <p:cNvSpPr txBox="1"/>
-          <p:nvPr/>
-        </p:nvSpPr>
-        <p:spPr>
-          <a:xfrm>
-            <a:off x="6772275" y="5391150"/>
-            <a:ext cx="3267075" cy="352425"/>
-          </a:xfrm>
-          <a:prstGeom prst="rect">
-            <a:avLst/>
-          </a:prstGeom>
-          <a:noFill/>
-          <a:ln/>
-        </p:spPr>
-        <p:txBody>
-          <a:bodyPr wrap="square" lIns="0" tIns="0" rIns="0" bIns="0" anchor="ctr"/>
-          <a:lstStyle/>
-          <a:p>
-            <a:pPr/>
-            <a:r>
-              <a:rPr sz="2100" b="1">
-                <a:solidFill>
-                  <a:srgbClr val="1C2340"/>
-                </a:solidFill>
-                <a:latin typeface="DM Sans"/>
-                <a:ea typeface="DM Sans"/>
-              </a:rPr>
-              <a:t>I waited for </a:t>
-            </a:r>
-            <a:pPr/>
-            <a:r>
-              <a:rPr sz="2100" b="1">
+          <p:cNvPr id="23" name=""/>
+          <p:cNvSpPr txBox="1"/>
+          <p:nvPr/>
+        </p:nvSpPr>
+        <p:spPr>
+          <a:xfrm>
+            <a:off x="6791325" y="5619750"/>
+            <a:ext cx="1952625" cy="495300"/>
+          </a:xfrm>
+          <a:prstGeom prst="rect">
+            <a:avLst/>
+          </a:prstGeom>
+          <a:noFill/>
+          <a:ln/>
+        </p:spPr>
+        <p:txBody>
+          <a:bodyPr wrap="square" lIns="0" tIns="0" rIns="0" bIns="0" anchor="ctr"/>
+          <a:lstStyle/>
+          <a:p>
+            <a:pPr/>
+            <a:r>
+              <a:rPr sz="3000" b="1">
                 <a:solidFill>
                   <a:srgbClr val="E8461E"/>
                 </a:solidFill>
@@ -13735,49 +14236,14 @@
             </a:r>
             <a:pPr/>
             <a:r>
-              <a:rPr sz="2100" b="1">
-                <a:solidFill>
-                  <a:srgbClr val="1C2340"/>
-                </a:solidFill>
-                <a:latin typeface="DM Sans"/>
-                <a:ea typeface="DM Sans"/>
-              </a:rPr>
-              <a:t> hour.</a:t>
-            </a:r>
-          </a:p>
-        </p:txBody>
-      </p:sp>
-      <p:sp>
-        <p:nvSpPr>
-          <p:cNvPr id="25" name=""/>
-          <p:cNvSpPr txBox="1"/>
-          <p:nvPr/>
-        </p:nvSpPr>
-        <p:spPr>
-          <a:xfrm>
-            <a:off x="6772275" y="5781675"/>
-            <a:ext cx="2543175" cy="257175"/>
-          </a:xfrm>
-          <a:prstGeom prst="rect">
-            <a:avLst/>
-          </a:prstGeom>
-          <a:noFill/>
-          <a:ln/>
-        </p:spPr>
-        <p:txBody>
-          <a:bodyPr wrap="square" lIns="0" tIns="0" rIns="0" bIns="0" anchor="ctr"/>
-          <a:lstStyle/>
-          <a:p>
-            <a:pPr/>
-            <a:r>
-              <a:rPr sz="1450">
-                <a:solidFill>
-                  <a:srgbClr val="4A5270"/>
-                </a:solidFill>
-                <a:latin typeface="Noto Sans JP"/>
-                <a:ea typeface="Noto Sans JP"/>
-              </a:rPr>
-              <a:t>私は1時間待ちました。</a:t>
+              <a:rPr sz="3000" b="1">
+                <a:solidFill>
+                  <a:srgbClr val="1C2340"/>
+                </a:solidFill>
+                <a:latin typeface="DM Sans"/>
+                <a:ea typeface="DM Sans"/>
+              </a:rPr>
+              <a:t> hour</a:t>
             </a:r>
           </a:p>
         </p:txBody>
@@ -13984,11 +14450,11 @@
         <p:spPr>
           <a:xfrm>
             <a:off x="685800" y="2028825"/>
-            <a:ext cx="5286375" cy="3514725"/>
+            <a:ext cx="5286375" cy="3400425"/>
           </a:xfrm>
           <a:prstGeom prst="roundRect">
             <a:avLst>
-              <a:gd name="adj" fmla="val 7588"/>
+              <a:gd name="adj" fmla="val 7843"/>
             </a:avLst>
           </a:prstGeom>
           <a:solidFill>
@@ -14012,7 +14478,7 @@
         </p:nvSpPr>
         <p:spPr>
           <a:xfrm>
-            <a:off x="1066800" y="2838450"/>
+            <a:off x="1066800" y="2781300"/>
             <a:ext cx="1676400" cy="600075"/>
           </a:xfrm>
           <a:prstGeom prst="rect">
@@ -14058,7 +14524,7 @@
         </p:nvSpPr>
         <p:spPr>
           <a:xfrm>
-            <a:off x="1066800" y="3533775"/>
+            <a:off x="1066800" y="3476625"/>
             <a:ext cx="3362325" cy="628650"/>
           </a:xfrm>
           <a:prstGeom prst="rect">
@@ -14115,7 +14581,7 @@
         </p:nvSpPr>
         <p:spPr>
           <a:xfrm>
-            <a:off x="1066800" y="4124325"/>
+            <a:off x="1066800" y="4067175"/>
             <a:ext cx="3362325" cy="628650"/>
           </a:xfrm>
           <a:prstGeom prst="rect">
@@ -14151,11 +14617,11 @@
         <p:spPr>
           <a:xfrm>
             <a:off x="6219825" y="2028825"/>
-            <a:ext cx="5286375" cy="3514725"/>
+            <a:ext cx="5286375" cy="3400425"/>
           </a:xfrm>
           <a:prstGeom prst="roundRect">
             <a:avLst>
-              <a:gd name="adj" fmla="val 7588"/>
+              <a:gd name="adj" fmla="val 7843"/>
             </a:avLst>
           </a:prstGeom>
           <a:solidFill>
@@ -14187,7 +14653,7 @@
         </p:blipFill>
         <p:spPr>
           <a:xfrm>
-            <a:off x="6762750" y="2476500"/>
+            <a:off x="6762750" y="2447925"/>
             <a:ext cx="1066800" cy="1066800"/>
           </a:xfrm>
           <a:prstGeom prst="rect">
@@ -14203,7 +14669,7 @@
         </p:nvSpPr>
         <p:spPr>
           <a:xfrm>
-            <a:off x="8153400" y="2295525"/>
+            <a:off x="8153400" y="2266950"/>
             <a:ext cx="1428750" cy="1428750"/>
           </a:xfrm>
           <a:prstGeom prst="ellipse">
@@ -14236,7 +14702,7 @@
         </p:blipFill>
         <p:spPr>
           <a:xfrm>
-            <a:off x="8334375" y="2476500"/>
+            <a:off x="8334375" y="2447925"/>
             <a:ext cx="1066800" cy="1066800"/>
           </a:xfrm>
           <a:prstGeom prst="rect">
@@ -14252,7 +14718,7 @@
         </p:nvSpPr>
         <p:spPr>
           <a:xfrm>
-            <a:off x="8505825" y="3495675"/>
+            <a:off x="8505825" y="3467100"/>
             <a:ext cx="723900" cy="323850"/>
           </a:xfrm>
           <a:prstGeom prst="roundRect">
@@ -14274,7 +14740,7 @@
         </p:nvSpPr>
         <p:spPr>
           <a:xfrm>
-            <a:off x="8382000" y="3524250"/>
+            <a:off x="8382000" y="3495675"/>
             <a:ext cx="971550" cy="257175"/>
           </a:xfrm>
           <a:prstGeom prst="rect">
@@ -14317,7 +14783,7 @@
         </p:blipFill>
         <p:spPr>
           <a:xfrm>
-            <a:off x="9906000" y="2476500"/>
+            <a:off x="9906000" y="2447925"/>
             <a:ext cx="1066800" cy="1066800"/>
           </a:xfrm>
           <a:prstGeom prst="rect">
@@ -14341,7 +14807,7 @@
         </p:blipFill>
         <p:spPr>
           <a:xfrm>
-            <a:off x="6762750" y="4029075"/>
+            <a:off x="6762750" y="3943350"/>
             <a:ext cx="1066800" cy="1066800"/>
           </a:xfrm>
           <a:prstGeom prst="rect">
@@ -14365,7 +14831,7 @@
         </p:blipFill>
         <p:spPr>
           <a:xfrm>
-            <a:off x="8334375" y="4029075"/>
+            <a:off x="8334375" y="3943350"/>
             <a:ext cx="1066800" cy="1066800"/>
           </a:xfrm>
           <a:prstGeom prst="rect">
@@ -14389,7 +14855,7 @@
         </p:blipFill>
         <p:spPr>
           <a:xfrm>
-            <a:off x="9906000" y="4029075"/>
+            <a:off x="9906000" y="3943350"/>
             <a:ext cx="1066800" cy="1066800"/>
           </a:xfrm>
           <a:prstGeom prst="rect">
@@ -14405,16 +14871,16 @@
         </p:nvSpPr>
         <p:spPr>
           <a:xfrm>
-            <a:off x="685800" y="5734050"/>
-            <a:ext cx="5314950" cy="704850"/>
+            <a:off x="685800" y="5600700"/>
+            <a:ext cx="5314950" cy="838200"/>
           </a:xfrm>
           <a:prstGeom prst="roundRect">
             <a:avLst>
-              <a:gd name="adj" fmla="val 37838"/>
+              <a:gd name="adj" fmla="val 31818"/>
             </a:avLst>
           </a:prstGeom>
           <a:solidFill>
-            <a:srgbClr val="FFFFFF"/>
+            <a:srgbClr val="FFE8DC"/>
           </a:solidFill>
           <a:ln/>
           <a:effectLst>
@@ -14429,22 +14895,37 @@
       <p:sp>
         <p:nvSpPr>
           <p:cNvPr id="21" name=""/>
-          <p:cNvSpPr/>
-          <p:nvPr/>
-        </p:nvSpPr>
-        <p:spPr>
-          <a:xfrm>
-            <a:off x="914400" y="5905500"/>
-            <a:ext cx="361950" cy="361950"/>
-          </a:xfrm>
-          <a:prstGeom prst="ellipse">
-            <a:avLst/>
-          </a:prstGeom>
-          <a:solidFill>
-            <a:srgbClr val="2F86CF"/>
-          </a:solidFill>
-          <a:ln/>
-        </p:spPr>
+          <p:cNvSpPr txBox="1"/>
+          <p:nvPr/>
+        </p:nvSpPr>
+        <p:spPr>
+          <a:xfrm>
+            <a:off x="914400" y="5838825"/>
+            <a:ext cx="1743075" cy="371475"/>
+          </a:xfrm>
+          <a:prstGeom prst="rect">
+            <a:avLst/>
+          </a:prstGeom>
+          <a:noFill/>
+          <a:ln/>
+        </p:spPr>
+        <p:txBody>
+          <a:bodyPr wrap="square" lIns="0" tIns="0" rIns="0" bIns="0" anchor="ctr"/>
+          <a:lstStyle/>
+          <a:p>
+            <a:pPr/>
+            <a:r>
+              <a:rPr sz="2250" b="1">
+                <a:solidFill>
+                  <a:srgbClr val="E8461E"/>
+                </a:solidFill>
+                <a:latin typeface="DM Sans"/>
+                <a:ea typeface="DM Sans"/>
+              </a:rPr>
+              <a:t>an apple</a:t>
+            </a:r>
+          </a:p>
+        </p:txBody>
       </p:sp>
       <p:sp>
         <p:nvSpPr>
@@ -14454,29 +14935,29 @@
         </p:nvSpPr>
         <p:spPr>
           <a:xfrm>
-            <a:off x="885825" y="5972175"/>
-            <a:ext cx="419100" cy="238125"/>
-          </a:xfrm>
-          <a:prstGeom prst="rect">
-            <a:avLst/>
-          </a:prstGeom>
-          <a:noFill/>
-          <a:ln/>
-        </p:spPr>
-        <p:txBody>
-          <a:bodyPr wrap="square" lIns="0" tIns="0" rIns="0" bIns="0" anchor="ctr"/>
-          <a:lstStyle/>
-          <a:p>
-            <a:pPr algn="ctr"/>
-            <a:r>
-              <a:rPr sz="1450" b="1">
-                <a:solidFill>
-                  <a:srgbClr val="FFFFFF"/>
-                </a:solidFill>
-                <a:latin typeface="DM Sans"/>
-                <a:ea typeface="DM Sans"/>
-              </a:rPr>
-              <a:t>1</a:t>
+            <a:off x="2286000" y="5734050"/>
+            <a:ext cx="1714500" cy="285750"/>
+          </a:xfrm>
+          <a:prstGeom prst="rect">
+            <a:avLst/>
+          </a:prstGeom>
+          <a:noFill/>
+          <a:ln/>
+        </p:spPr>
+        <p:txBody>
+          <a:bodyPr wrap="square" lIns="0" tIns="0" rIns="0" bIns="0" anchor="ctr"/>
+          <a:lstStyle/>
+          <a:p>
+            <a:pPr/>
+            <a:r>
+              <a:rPr sz="1600">
+                <a:solidFill>
+                  <a:srgbClr val="1C2340"/>
+                </a:solidFill>
+                <a:latin typeface="Noto Sans JP"/>
+                <a:ea typeface="Noto Sans JP"/>
+              </a:rPr>
+              <a:t>どれでもいい</a:t>
             </a:r>
           </a:p>
         </p:txBody>
@@ -14489,51 +14970,29 @@
         </p:nvSpPr>
         <p:spPr>
           <a:xfrm>
-            <a:off x="1409700" y="5934075"/>
-            <a:ext cx="4676775" cy="304800"/>
-          </a:xfrm>
-          <a:prstGeom prst="rect">
-            <a:avLst/>
-          </a:prstGeom>
-          <a:noFill/>
-          <a:ln/>
-        </p:spPr>
-        <p:txBody>
-          <a:bodyPr wrap="square" lIns="0" tIns="0" rIns="0" bIns="0" anchor="ctr"/>
-          <a:lstStyle/>
-          <a:p>
-            <a:pPr/>
-            <a:r>
-              <a:rPr sz="1650">
-                <a:solidFill>
-                  <a:srgbClr val="1C2340"/>
-                </a:solidFill>
-                <a:latin typeface="Noto Sans JP"/>
-                <a:ea typeface="Noto Sans JP"/>
-              </a:rPr>
-              <a:t>どの人・どの物のことか</a:t>
-            </a:r>
-            <a:pPr/>
-            <a:r>
-              <a:rPr sz="1650" b="1">
-                <a:solidFill>
-                  <a:srgbClr val="1C2340"/>
-                </a:solidFill>
-                <a:latin typeface="Noto Sans JP"/>
-                <a:ea typeface="Noto Sans JP"/>
-              </a:rPr>
-              <a:t>特定できる</a:t>
-            </a:r>
-            <a:pPr/>
-            <a:r>
-              <a:rPr sz="1650">
-                <a:solidFill>
-                  <a:srgbClr val="1C2340"/>
-                </a:solidFill>
-                <a:latin typeface="Noto Sans JP"/>
-                <a:ea typeface="Noto Sans JP"/>
-              </a:rPr>
-              <a:t>とき</a:t>
+            <a:off x="2286000" y="6019800"/>
+            <a:ext cx="1390650" cy="285750"/>
+          </a:xfrm>
+          <a:prstGeom prst="rect">
+            <a:avLst/>
+          </a:prstGeom>
+          <a:noFill/>
+          <a:ln/>
+        </p:spPr>
+        <p:txBody>
+          <a:bodyPr wrap="square" lIns="0" tIns="0" rIns="0" bIns="0" anchor="ctr"/>
+          <a:lstStyle/>
+          <a:p>
+            <a:pPr/>
+            <a:r>
+              <a:rPr sz="1600">
+                <a:solidFill>
+                  <a:srgbClr val="1C2340"/>
+                </a:solidFill>
+                <a:latin typeface="Noto Sans JP"/>
+                <a:ea typeface="Noto Sans JP"/>
+              </a:rPr>
+              <a:t>りんご1つ</a:t>
             </a:r>
           </a:p>
         </p:txBody>
@@ -14546,16 +15005,16 @@
         </p:nvSpPr>
         <p:spPr>
           <a:xfrm>
-            <a:off x="6191250" y="5734050"/>
-            <a:ext cx="5314950" cy="704850"/>
+            <a:off x="6191250" y="5600700"/>
+            <a:ext cx="5314950" cy="838200"/>
           </a:xfrm>
           <a:prstGeom prst="roundRect">
             <a:avLst>
-              <a:gd name="adj" fmla="val 37838"/>
+              <a:gd name="adj" fmla="val 31818"/>
             </a:avLst>
           </a:prstGeom>
           <a:solidFill>
-            <a:srgbClr val="FFFFFF"/>
+            <a:srgbClr val="DDEFFC"/>
           </a:solidFill>
           <a:ln/>
           <a:effectLst>
@@ -14570,22 +15029,37 @@
       <p:sp>
         <p:nvSpPr>
           <p:cNvPr id="25" name=""/>
-          <p:cNvSpPr/>
-          <p:nvPr/>
-        </p:nvSpPr>
-        <p:spPr>
-          <a:xfrm>
-            <a:off x="6419850" y="5905500"/>
-            <a:ext cx="361950" cy="361950"/>
-          </a:xfrm>
-          <a:prstGeom prst="ellipse">
-            <a:avLst/>
-          </a:prstGeom>
-          <a:solidFill>
-            <a:srgbClr val="2F86CF"/>
-          </a:solidFill>
-          <a:ln/>
-        </p:spPr>
+          <p:cNvSpPr txBox="1"/>
+          <p:nvPr/>
+        </p:nvSpPr>
+        <p:spPr>
+          <a:xfrm>
+            <a:off x="6419850" y="5838825"/>
+            <a:ext cx="1885950" cy="371475"/>
+          </a:xfrm>
+          <a:prstGeom prst="rect">
+            <a:avLst/>
+          </a:prstGeom>
+          <a:noFill/>
+          <a:ln/>
+        </p:spPr>
+        <p:txBody>
+          <a:bodyPr wrap="square" lIns="0" tIns="0" rIns="0" bIns="0" anchor="ctr"/>
+          <a:lstStyle/>
+          <a:p>
+            <a:pPr/>
+            <a:r>
+              <a:rPr sz="2250" b="1">
+                <a:solidFill>
+                  <a:srgbClr val="2F86CF"/>
+                </a:solidFill>
+                <a:latin typeface="DM Sans"/>
+                <a:ea typeface="DM Sans"/>
+              </a:rPr>
+              <a:t>the apple</a:t>
+            </a:r>
+          </a:p>
+        </p:txBody>
       </p:sp>
       <p:sp>
         <p:nvSpPr>
@@ -14595,29 +15069,29 @@
         </p:nvSpPr>
         <p:spPr>
           <a:xfrm>
-            <a:off x="6372225" y="5972175"/>
-            <a:ext cx="466725" cy="238125"/>
-          </a:xfrm>
-          <a:prstGeom prst="rect">
-            <a:avLst/>
-          </a:prstGeom>
-          <a:noFill/>
-          <a:ln/>
-        </p:spPr>
-        <p:txBody>
-          <a:bodyPr wrap="square" lIns="0" tIns="0" rIns="0" bIns="0" anchor="ctr"/>
-          <a:lstStyle/>
-          <a:p>
-            <a:pPr algn="ctr"/>
-            <a:r>
-              <a:rPr sz="1450" b="1">
-                <a:solidFill>
-                  <a:srgbClr val="FFFFFF"/>
-                </a:solidFill>
-                <a:latin typeface="DM Sans"/>
-                <a:ea typeface="DM Sans"/>
-              </a:rPr>
-              <a:t>2</a:t>
+            <a:off x="7915275" y="5734050"/>
+            <a:ext cx="2647950" cy="285750"/>
+          </a:xfrm>
+          <a:prstGeom prst="rect">
+            <a:avLst/>
+          </a:prstGeom>
+          <a:noFill/>
+          <a:ln/>
+        </p:spPr>
+        <p:txBody>
+          <a:bodyPr wrap="square" lIns="0" tIns="0" rIns="0" bIns="0" anchor="ctr"/>
+          <a:lstStyle/>
+          <a:p>
+            <a:pPr/>
+            <a:r>
+              <a:rPr sz="1600">
+                <a:solidFill>
+                  <a:srgbClr val="1C2340"/>
+                </a:solidFill>
+                <a:latin typeface="Noto Sans JP"/>
+                <a:ea typeface="Noto Sans JP"/>
+              </a:rPr>
+              <a:t>「それ！」と指させる</a:t>
             </a:r>
           </a:p>
         </p:txBody>
@@ -14630,51 +15104,29 @@
         </p:nvSpPr>
         <p:spPr>
           <a:xfrm>
-            <a:off x="6915150" y="5934075"/>
-            <a:ext cx="4200525" cy="304800"/>
-          </a:xfrm>
-          <a:prstGeom prst="rect">
-            <a:avLst/>
-          </a:prstGeom>
-          <a:noFill/>
-          <a:ln/>
-        </p:spPr>
-        <p:txBody>
-          <a:bodyPr wrap="square" lIns="0" tIns="0" rIns="0" bIns="0" anchor="ctr"/>
-          <a:lstStyle/>
-          <a:p>
-            <a:pPr/>
-            <a:r>
-              <a:rPr sz="1650">
-                <a:solidFill>
-                  <a:srgbClr val="1C2340"/>
-                </a:solidFill>
-                <a:latin typeface="Noto Sans JP"/>
-                <a:ea typeface="Noto Sans JP"/>
-              </a:rPr>
-              <a:t>話し手と聞き手の</a:t>
-            </a:r>
-            <a:pPr/>
-            <a:r>
-              <a:rPr sz="1650" b="1">
-                <a:solidFill>
-                  <a:srgbClr val="1C2340"/>
-                </a:solidFill>
-                <a:latin typeface="Noto Sans JP"/>
-                <a:ea typeface="Noto Sans JP"/>
-              </a:rPr>
-              <a:t>両方が分かる</a:t>
-            </a:r>
-            <a:pPr/>
-            <a:r>
-              <a:rPr sz="1650">
-                <a:solidFill>
-                  <a:srgbClr val="1C2340"/>
-                </a:solidFill>
-                <a:latin typeface="Noto Sans JP"/>
-                <a:ea typeface="Noto Sans JP"/>
-              </a:rPr>
-              <a:t>とき</a:t>
+            <a:off x="7915275" y="6019800"/>
+            <a:ext cx="2409825" cy="285750"/>
+          </a:xfrm>
+          <a:prstGeom prst="rect">
+            <a:avLst/>
+          </a:prstGeom>
+          <a:noFill/>
+          <a:ln/>
+        </p:spPr>
+        <p:txBody>
+          <a:bodyPr wrap="square" lIns="0" tIns="0" rIns="0" bIns="0" anchor="ctr"/>
+          <a:lstStyle/>
+          <a:p>
+            <a:pPr/>
+            <a:r>
+              <a:rPr sz="1600">
+                <a:solidFill>
+                  <a:srgbClr val="1C2340"/>
+                </a:solidFill>
+                <a:latin typeface="Noto Sans JP"/>
+                <a:ea typeface="Noto Sans JP"/>
+              </a:rPr>
+              <a:t>その（緑の）りんご</a:t>
             </a:r>
           </a:p>
         </p:txBody>

</xml_diff>

<commit_message>
Remove card shadows and split 冠詞 Part 2 into Part 2 and Part 3
Chrome baked every card's soft box-shadow into the PDF as a gray image,
which some viewers drew as gray bands over the cards. The shared
stylesheet and the proper-noun chips no longer use box-shadow, so the
PDFs carry no shadow images and the PPTX files no shadows.

Part 2 now ends at the まとめ slide (16 slides). Its 無冠詞 slides move to
a new Part 3 deck in articles-3 with its own cover (13 slides), and the
practice deck moves to articles-4 as video 4, with STEP 3 now pointing
at 動画3. All four 冠詞 decks are rebuilt.

Co-Authored-By: Claude Opus 5.5 <noreply@anthropic.com>
Claude-Session: https://claude.ai/code/session_01AdzV2rtokspoPMcfpFKx4K
</commit_message>
<xml_diff>
--- a/matome/a-the/a-the-slides.pptx
+++ b/matome/a-the/a-the-slides.pptx
@@ -472,13 +472,6 @@
             <a:srgbClr val="FFDCCB"/>
           </a:solidFill>
           <a:ln/>
-          <a:effectLst>
-            <a:outerShdw sx="100000" sy="100000" kx="0" ky="0" algn="bl" rotWithShape="0" blurRad="152400" dist="50800" dir="5400000">
-              <a:srgbClr val="22304A">
-                <a:alpha val="10000"/>
-              </a:srgbClr>
-            </a:outerShdw>
-          </a:effectLst>
         </p:spPr>
       </p:sp>
       <p:sp>
@@ -799,13 +792,6 @@
             <a:srgbClr val="FFFFFF"/>
           </a:solidFill>
           <a:ln/>
-          <a:effectLst>
-            <a:outerShdw sx="100000" sy="100000" kx="0" ky="0" algn="bl" rotWithShape="0" blurRad="152400" dist="50800" dir="5400000">
-              <a:srgbClr val="22304A">
-                <a:alpha val="10000"/>
-              </a:srgbClr>
-            </a:outerShdw>
-          </a:effectLst>
         </p:spPr>
       </p:sp>
       <p:sp>
@@ -929,13 +915,6 @@
             <a:srgbClr val="FFFFFF"/>
           </a:solidFill>
           <a:ln/>
-          <a:effectLst>
-            <a:outerShdw sx="100000" sy="100000" kx="0" ky="0" algn="bl" rotWithShape="0" blurRad="152400" dist="50800" dir="5400000">
-              <a:srgbClr val="22304A">
-                <a:alpha val="10000"/>
-              </a:srgbClr>
-            </a:outerShdw>
-          </a:effectLst>
         </p:spPr>
       </p:sp>
       <p:sp>
@@ -1094,13 +1073,6 @@
             <a:srgbClr val="FFFFFF"/>
           </a:solidFill>
           <a:ln/>
-          <a:effectLst>
-            <a:outerShdw sx="100000" sy="100000" kx="0" ky="0" algn="bl" rotWithShape="0" blurRad="152400" dist="50800" dir="5400000">
-              <a:srgbClr val="22304A">
-                <a:alpha val="10000"/>
-              </a:srgbClr>
-            </a:outerShdw>
-          </a:effectLst>
         </p:spPr>
       </p:sp>
       <p:pic>
@@ -1331,13 +1303,6 @@
             <a:srgbClr val="FFFFFF"/>
           </a:solidFill>
           <a:ln/>
-          <a:effectLst>
-            <a:outerShdw sx="100000" sy="100000" kx="0" ky="0" algn="bl" rotWithShape="0" blurRad="152400" dist="50800" dir="5400000">
-              <a:srgbClr val="22304A">
-                <a:alpha val="10000"/>
-              </a:srgbClr>
-            </a:outerShdw>
-          </a:effectLst>
         </p:spPr>
       </p:sp>
       <p:pic>
@@ -1568,13 +1533,6 @@
             <a:srgbClr val="FFFFFF"/>
           </a:solidFill>
           <a:ln/>
-          <a:effectLst>
-            <a:outerShdw sx="100000" sy="100000" kx="0" ky="0" algn="bl" rotWithShape="0" blurRad="152400" dist="50800" dir="5400000">
-              <a:srgbClr val="22304A">
-                <a:alpha val="10000"/>
-              </a:srgbClr>
-            </a:outerShdw>
-          </a:effectLst>
         </p:spPr>
       </p:sp>
       <p:pic>
@@ -1963,13 +1921,6 @@
             <a:srgbClr val="FFFFFF"/>
           </a:solidFill>
           <a:ln/>
-          <a:effectLst>
-            <a:outerShdw sx="100000" sy="100000" kx="0" ky="0" algn="bl" rotWithShape="0" blurRad="152400" dist="50800" dir="5400000">
-              <a:srgbClr val="22304A">
-                <a:alpha val="10000"/>
-              </a:srgbClr>
-            </a:outerShdw>
-          </a:effectLst>
         </p:spPr>
       </p:sp>
       <p:pic>
@@ -2563,13 +2514,6 @@
             <a:srgbClr val="FFFFFF"/>
           </a:solidFill>
           <a:ln/>
-          <a:effectLst>
-            <a:outerShdw sx="100000" sy="100000" kx="0" ky="0" algn="bl" rotWithShape="0" blurRad="152400" dist="50800" dir="5400000">
-              <a:srgbClr val="22304A">
-                <a:alpha val="10000"/>
-              </a:srgbClr>
-            </a:outerShdw>
-          </a:effectLst>
         </p:spPr>
       </p:sp>
       <p:pic>
@@ -2870,13 +2814,6 @@
             <a:srgbClr val="FFFFFF"/>
           </a:solidFill>
           <a:ln/>
-          <a:effectLst>
-            <a:outerShdw sx="100000" sy="100000" kx="0" ky="0" algn="bl" rotWithShape="0" blurRad="152400" dist="50800" dir="5400000">
-              <a:srgbClr val="22304A">
-                <a:alpha val="10000"/>
-              </a:srgbClr>
-            </a:outerShdw>
-          </a:effectLst>
         </p:spPr>
       </p:sp>
       <p:sp>
@@ -3550,13 +3487,6 @@
             <a:srgbClr val="FFFFFF"/>
           </a:solidFill>
           <a:ln/>
-          <a:effectLst>
-            <a:outerShdw sx="100000" sy="100000" kx="0" ky="0" algn="bl" rotWithShape="0" blurRad="152400" dist="50800" dir="5400000">
-              <a:srgbClr val="22304A">
-                <a:alpha val="10000"/>
-              </a:srgbClr>
-            </a:outerShdw>
-          </a:effectLst>
         </p:spPr>
       </p:sp>
       <p:sp>
@@ -3671,13 +3601,6 @@
             <a:srgbClr val="FFFFFF"/>
           </a:solidFill>
           <a:ln/>
-          <a:effectLst>
-            <a:outerShdw sx="100000" sy="100000" kx="0" ky="0" algn="bl" rotWithShape="0" blurRad="152400" dist="50800" dir="5400000">
-              <a:srgbClr val="22304A">
-                <a:alpha val="10000"/>
-              </a:srgbClr>
-            </a:outerShdw>
-          </a:effectLst>
         </p:spPr>
       </p:sp>
       <p:sp>
@@ -3805,13 +3728,6 @@
             <a:srgbClr val="FFFFFF"/>
           </a:solidFill>
           <a:ln/>
-          <a:effectLst>
-            <a:outerShdw sx="100000" sy="100000" kx="0" ky="0" algn="bl" rotWithShape="0" blurRad="152400" dist="50800" dir="5400000">
-              <a:srgbClr val="22304A">
-                <a:alpha val="10000"/>
-              </a:srgbClr>
-            </a:outerShdw>
-          </a:effectLst>
         </p:spPr>
       </p:sp>
       <p:sp>
@@ -3961,13 +3877,6 @@
             <a:srgbClr val="FFFFFF"/>
           </a:solidFill>
           <a:ln/>
-          <a:effectLst>
-            <a:outerShdw sx="100000" sy="100000" kx="0" ky="0" algn="bl" rotWithShape="0" blurRad="152400" dist="50800" dir="5400000">
-              <a:srgbClr val="22304A">
-                <a:alpha val="10000"/>
-              </a:srgbClr>
-            </a:outerShdw>
-          </a:effectLst>
         </p:spPr>
       </p:sp>
       <p:sp>
@@ -4286,13 +4195,6 @@
             <a:srgbClr val="FFFFFF"/>
           </a:solidFill>
           <a:ln/>
-          <a:effectLst>
-            <a:outerShdw sx="100000" sy="100000" kx="0" ky="0" algn="bl" rotWithShape="0" blurRad="152400" dist="50800" dir="5400000">
-              <a:srgbClr val="22304A">
-                <a:alpha val="10000"/>
-              </a:srgbClr>
-            </a:outerShdw>
-          </a:effectLst>
         </p:spPr>
       </p:sp>
       <p:pic>
@@ -4886,13 +4788,6 @@
             <a:srgbClr val="FFFFFF"/>
           </a:solidFill>
           <a:ln/>
-          <a:effectLst>
-            <a:outerShdw sx="100000" sy="100000" kx="0" ky="0" algn="bl" rotWithShape="0" blurRad="152400" dist="50800" dir="5400000">
-              <a:srgbClr val="22304A">
-                <a:alpha val="10000"/>
-              </a:srgbClr>
-            </a:outerShdw>
-          </a:effectLst>
         </p:spPr>
       </p:sp>
       <p:pic>
@@ -5193,13 +5088,6 @@
             <a:srgbClr val="FFFFFF"/>
           </a:solidFill>
           <a:ln/>
-          <a:effectLst>
-            <a:outerShdw sx="100000" sy="100000" kx="0" ky="0" algn="bl" rotWithShape="0" blurRad="152400" dist="50800" dir="5400000">
-              <a:srgbClr val="22304A">
-                <a:alpha val="10000"/>
-              </a:srgbClr>
-            </a:outerShdw>
-          </a:effectLst>
         </p:spPr>
       </p:sp>
       <p:sp>
@@ -6186,13 +6074,6 @@
             <a:srgbClr val="FFFFFF"/>
           </a:solidFill>
           <a:ln/>
-          <a:effectLst>
-            <a:outerShdw sx="100000" sy="100000" kx="0" ky="0" algn="bl" rotWithShape="0" blurRad="152400" dist="50800" dir="5400000">
-              <a:srgbClr val="22304A">
-                <a:alpha val="10000"/>
-              </a:srgbClr>
-            </a:outerShdw>
-          </a:effectLst>
         </p:spPr>
       </p:sp>
       <p:sp>
@@ -6392,13 +6273,6 @@
             <a:srgbClr val="FFFFFF"/>
           </a:solidFill>
           <a:ln/>
-          <a:effectLst>
-            <a:outerShdw sx="100000" sy="100000" kx="0" ky="0" algn="bl" rotWithShape="0" blurRad="152400" dist="50800" dir="5400000">
-              <a:srgbClr val="22304A">
-                <a:alpha val="10000"/>
-              </a:srgbClr>
-            </a:outerShdw>
-          </a:effectLst>
         </p:spPr>
       </p:sp>
       <p:sp>
@@ -6598,13 +6472,6 @@
             <a:srgbClr val="FFFFFF"/>
           </a:solidFill>
           <a:ln/>
-          <a:effectLst>
-            <a:outerShdw sx="100000" sy="100000" kx="0" ky="0" algn="bl" rotWithShape="0" blurRad="152400" dist="50800" dir="5400000">
-              <a:srgbClr val="22304A">
-                <a:alpha val="10000"/>
-              </a:srgbClr>
-            </a:outerShdw>
-          </a:effectLst>
         </p:spPr>
       </p:sp>
       <p:sp>
@@ -6804,13 +6671,6 @@
             <a:srgbClr val="FFFFFF"/>
           </a:solidFill>
           <a:ln/>
-          <a:effectLst>
-            <a:outerShdw sx="100000" sy="100000" kx="0" ky="0" algn="bl" rotWithShape="0" blurRad="152400" dist="50800" dir="5400000">
-              <a:srgbClr val="22304A">
-                <a:alpha val="10000"/>
-              </a:srgbClr>
-            </a:outerShdw>
-          </a:effectLst>
         </p:spPr>
       </p:sp>
       <p:sp>
@@ -7010,13 +6870,6 @@
             <a:srgbClr val="FFFFFF"/>
           </a:solidFill>
           <a:ln/>
-          <a:effectLst>
-            <a:outerShdw sx="100000" sy="100000" kx="0" ky="0" algn="bl" rotWithShape="0" blurRad="152400" dist="50800" dir="5400000">
-              <a:srgbClr val="22304A">
-                <a:alpha val="10000"/>
-              </a:srgbClr>
-            </a:outerShdw>
-          </a:effectLst>
         </p:spPr>
       </p:sp>
       <p:sp>
@@ -7491,13 +7344,6 @@
             <a:srgbClr val="FFFFFF"/>
           </a:solidFill>
           <a:ln/>
-          <a:effectLst>
-            <a:outerShdw sx="100000" sy="100000" kx="0" ky="0" algn="bl" rotWithShape="0" blurRad="152400" dist="50800" dir="5400000">
-              <a:srgbClr val="22304A">
-                <a:alpha val="10000"/>
-              </a:srgbClr>
-            </a:outerShdw>
-          </a:effectLst>
         </p:spPr>
       </p:sp>
       <p:sp>
@@ -7704,13 +7550,6 @@
             <a:srgbClr val="FFFFFF"/>
           </a:solidFill>
           <a:ln/>
-          <a:effectLst>
-            <a:outerShdw sx="100000" sy="100000" kx="0" ky="0" algn="bl" rotWithShape="0" blurRad="152400" dist="50800" dir="5400000">
-              <a:srgbClr val="22304A">
-                <a:alpha val="10000"/>
-              </a:srgbClr>
-            </a:outerShdw>
-          </a:effectLst>
         </p:spPr>
       </p:sp>
       <p:sp>
@@ -7917,13 +7756,6 @@
             <a:srgbClr val="FFFFFF"/>
           </a:solidFill>
           <a:ln/>
-          <a:effectLst>
-            <a:outerShdw sx="100000" sy="100000" kx="0" ky="0" algn="bl" rotWithShape="0" blurRad="152400" dist="50800" dir="5400000">
-              <a:srgbClr val="22304A">
-                <a:alpha val="10000"/>
-              </a:srgbClr>
-            </a:outerShdw>
-          </a:effectLst>
         </p:spPr>
       </p:sp>
       <p:sp>
@@ -8255,13 +8087,6 @@
             <a:srgbClr val="FFFFFF"/>
           </a:solidFill>
           <a:ln/>
-          <a:effectLst>
-            <a:outerShdw sx="100000" sy="100000" kx="0" ky="0" algn="bl" rotWithShape="0" blurRad="152400" dist="50800" dir="5400000">
-              <a:srgbClr val="22304A">
-                <a:alpha val="10000"/>
-              </a:srgbClr>
-            </a:outerShdw>
-          </a:effectLst>
         </p:spPr>
       </p:sp>
       <p:sp>
@@ -8675,13 +8500,6 @@
             <a:srgbClr val="FFFFFF"/>
           </a:solidFill>
           <a:ln/>
-          <a:effectLst>
-            <a:outerShdw sx="100000" sy="100000" kx="0" ky="0" algn="bl" rotWithShape="0" blurRad="152400" dist="50800" dir="5400000">
-              <a:srgbClr val="22304A">
-                <a:alpha val="10000"/>
-              </a:srgbClr>
-            </a:outerShdw>
-          </a:effectLst>
         </p:spPr>
       </p:sp>
       <p:sp>
@@ -8987,13 +8805,6 @@
             <a:srgbClr val="FFFFFF"/>
           </a:solidFill>
           <a:ln/>
-          <a:effectLst>
-            <a:outerShdw sx="100000" sy="100000" kx="0" ky="0" algn="bl" rotWithShape="0" blurRad="152400" dist="50800" dir="5400000">
-              <a:srgbClr val="22304A">
-                <a:alpha val="10000"/>
-              </a:srgbClr>
-            </a:outerShdw>
-          </a:effectLst>
         </p:spPr>
       </p:sp>
       <p:sp>
@@ -9488,13 +9299,6 @@
             <a:srgbClr val="FFE8DC"/>
           </a:solidFill>
           <a:ln/>
-          <a:effectLst>
-            <a:outerShdw sx="100000" sy="100000" kx="0" ky="0" algn="bl" rotWithShape="0" blurRad="152400" dist="50800" dir="5400000">
-              <a:srgbClr val="22304A">
-                <a:alpha val="10000"/>
-              </a:srgbClr>
-            </a:outerShdw>
-          </a:effectLst>
         </p:spPr>
       </p:sp>
       <p:sp>
@@ -9785,13 +9589,6 @@
             <a:srgbClr val="FFFFFF"/>
           </a:solidFill>
           <a:ln/>
-          <a:effectLst>
-            <a:outerShdw sx="100000" sy="100000" kx="0" ky="0" algn="bl" rotWithShape="0" blurRad="152400" dist="50800" dir="5400000">
-              <a:srgbClr val="22304A">
-                <a:alpha val="10000"/>
-              </a:srgbClr>
-            </a:outerShdw>
-          </a:effectLst>
         </p:spPr>
       </p:sp>
       <p:pic>
@@ -10763,13 +10560,6 @@
             <a:srgbClr val="FFFFFF"/>
           </a:solidFill>
           <a:ln/>
-          <a:effectLst>
-            <a:outerShdw sx="100000" sy="100000" kx="0" ky="0" algn="bl" rotWithShape="0" blurRad="152400" dist="50800" dir="5400000">
-              <a:srgbClr val="22304A">
-                <a:alpha val="10000"/>
-              </a:srgbClr>
-            </a:outerShdw>
-          </a:effectLst>
         </p:spPr>
       </p:sp>
       <p:sp>
@@ -12825,13 +12615,6 @@
             <a:srgbClr val="FFFFFF"/>
           </a:solidFill>
           <a:ln/>
-          <a:effectLst>
-            <a:outerShdw sx="100000" sy="100000" kx="0" ky="0" algn="bl" rotWithShape="0" blurRad="152400" dist="50800" dir="5400000">
-              <a:srgbClr val="22304A">
-                <a:alpha val="10000"/>
-              </a:srgbClr>
-            </a:outerShdw>
-          </a:effectLst>
         </p:spPr>
       </p:sp>
       <p:pic>
@@ -13175,13 +12958,6 @@
             <a:srgbClr val="FFFFFF"/>
           </a:solidFill>
           <a:ln/>
-          <a:effectLst>
-            <a:outerShdw sx="100000" sy="100000" kx="0" ky="0" algn="bl" rotWithShape="0" blurRad="152400" dist="50800" dir="5400000">
-              <a:srgbClr val="22304A">
-                <a:alpha val="10000"/>
-              </a:srgbClr>
-            </a:outerShdw>
-          </a:effectLst>
         </p:spPr>
       </p:sp>
       <p:pic>
@@ -13661,13 +13437,6 @@
             <a:srgbClr val="DDEFFC"/>
           </a:solidFill>
           <a:ln/>
-          <a:effectLst>
-            <a:outerShdw sx="100000" sy="100000" kx="0" ky="0" algn="bl" rotWithShape="0" blurRad="152400" dist="50800" dir="5400000">
-              <a:srgbClr val="22304A">
-                <a:alpha val="10000"/>
-              </a:srgbClr>
-            </a:outerShdw>
-          </a:effectLst>
         </p:spPr>
       </p:sp>
       <p:sp>
@@ -13828,13 +13597,6 @@
             <a:srgbClr val="FFFFFF"/>
           </a:solidFill>
           <a:ln/>
-          <a:effectLst>
-            <a:outerShdw sx="100000" sy="100000" kx="0" ky="0" algn="bl" rotWithShape="0" blurRad="152400" dist="50800" dir="5400000">
-              <a:srgbClr val="22304A">
-                <a:alpha val="10000"/>
-              </a:srgbClr>
-            </a:outerShdw>
-          </a:effectLst>
         </p:spPr>
       </p:sp>
       <p:pic>
@@ -14083,13 +13845,6 @@
             <a:srgbClr val="FFE8DC"/>
           </a:solidFill>
           <a:ln/>
-          <a:effectLst>
-            <a:outerShdw sx="100000" sy="100000" kx="0" ky="0" algn="bl" rotWithShape="0" blurRad="152400" dist="50800" dir="5400000">
-              <a:srgbClr val="22304A">
-                <a:alpha val="10000"/>
-              </a:srgbClr>
-            </a:outerShdw>
-          </a:effectLst>
         </p:spPr>
       </p:sp>
       <p:sp>
@@ -14217,13 +13972,6 @@
             <a:srgbClr val="DDEFFC"/>
           </a:solidFill>
           <a:ln/>
-          <a:effectLst>
-            <a:outerShdw sx="100000" sy="100000" kx="0" ky="0" algn="bl" rotWithShape="0" blurRad="152400" dist="50800" dir="5400000">
-              <a:srgbClr val="22304A">
-                <a:alpha val="10000"/>
-              </a:srgbClr>
-            </a:outerShdw>
-          </a:effectLst>
         </p:spPr>
       </p:sp>
       <p:sp>

</xml_diff>